<commit_message>
added bunch of resources to BUS 634
</commit_message>
<xml_diff>
--- a/Classes/BUS 500, Foundations for Business Impact/Week 1/BAVARIAN.CYRUS.BUSINESS_PROFILE_ASSIGNMENT.pptx
+++ b/Classes/BUS 500, Foundations for Business Impact/Week 1/BAVARIAN.CYRUS.BUSINESS_PROFILE_ASSIGNMENT.pptx
@@ -1354,9 +1354,39 @@
           <a:bodyPr/>
           <a:lstStyle/>
           <a:p>
+            <a:endParaRPr lang="en-US" dirty="0"/>
+          </a:p>
+          <a:p>
             <a:r>
               <a:rPr lang="en-US" dirty="0"/>
-              <a:t>Broadcom WSD’s business is designed around a Functional Organizational structure which is an effective structure for a high-volume R&amp;D manufacturing facility. The key to success is the strong focus on role/responsibility which allows individual groups to dive deep into their skillsets and bring innovation to a rapidly changing environment. Technology developments are achieved by ensuring every step of the process has an owner who maintains a sense of urgency when monitoring and improving their process. Managers have a narrow span of control which ensures each functional group remains focused on their specialty and can deliver daily. Defects and Failures that occur in this type of organization are easy to detect and trace to the responsible group, offering a pipeline for quality management teams to innovate and drive continuous improvement initiatives. The main drawbacks in this type of organizational structure is the difficulty to standardize on operations as each functional group has a preference for how they accomplishing objectives. Special-case scenarios and tribal knowledge cause confusion when attempting to transfer solutions across groups. Each area plays a critical role in the overall success of the company as the final result of every groups work results in one final product. Of all of the groups, the most critical would be Supply Chain and Cleanroom. The Cleanroom group is responsible for ensuring the fabrication facility is operational and adheres to the local environmental laws and regulations. Supply Chain ensures that the necessary materials and chemicals are available to actually build the product. </a:t>
+              <a:t>Broadcom WSD in Fort Collins is a hierarchical functional organization, not a flat one. Broadcom the corporation is divisional (wireless vs. other semiconductor and software businesses). Inside the Fort Collins fab, people are grouped by specialty under a General Manager and Fab Manager, with a chain of command several layers deep: GM → Fab Manager → function → group → technicians or shifts.</a:t>
+            </a:r>
+          </a:p>
+          <a:p>
+            <a:endParaRPr lang="en-US" dirty="0"/>
+          </a:p>
+          <a:p>
+            <a:r>
+              <a:rPr lang="en-US" dirty="0"/>
+              <a:t>Does this help us hit our objectives? WSD’s objectives are 24/7 output, yield/quality, and keeping up with smartphone production ramps. The functional model does support that. Each process step has an owner, first-line managers have a narrow span of control, and defects are easy to trace to a responsible group. That is how a high-volume R&amp;D fab stays accountable when the product and the process both change quickly.</a:t>
+            </a:r>
+          </a:p>
+          <a:p>
+            <a:endParaRPr lang="en-US" dirty="0"/>
+          </a:p>
+          <a:p>
+            <a:r>
+              <a:rPr lang="en-US" dirty="0"/>
+              <a:t>The tradeoff is silos. Functions get very good at their own method, so it is hard to standardize work or move a solution from one group to another. Tribal knowledge and special cases slow cross-functional work — exactly when a yield excursion or a new product needs Equipment, Yield, R&amp;D, and Supply Chain in the same room. Also, “narrow span” is true at the group level; the Fab Manager layer is actually wide (seven functions). That is the hierarchical tradeoff from class: strong specialty focus, longer chain of command, more coordination cost.</a:t>
+            </a:r>
+          </a:p>
+          <a:p>
+            <a:endParaRPr lang="en-US" dirty="0"/>
+          </a:p>
+          <a:p>
+            <a:r>
+              <a:rPr lang="en-US" dirty="0"/>
+              <a:t>Key functions. Every box on the chart exists because one wafer becomes one filter. The two I would call most critical to keeping the factory able to run are Supply Chain and Cleanroom. Supply Chain (logistics, procurement, materials) is the only reason chemicals and parts are on hand for a 24/7 line. Cleanroom (including EHS) is the only reason the facility stays up and legal. Equipment/Process, Yield, and R&amp;D are equally critical to whether the filter is worth shipping — they own process capability, defect reduction, and the technology the customer actually buys. If any of those fail, either the line stops or the design win does not hold.</a:t>
             </a:r>
           </a:p>
         </p:txBody>

</xml_diff>

<commit_message>
added Week 2 655 discussion prompt
</commit_message>
<xml_diff>
--- a/Classes/BUS 500, Foundations for Business Impact/Week 1/BAVARIAN.CYRUS.BUSINESS_PROFILE_ASSIGNMENT.pptx
+++ b/Classes/BUS 500, Foundations for Business Impact/Week 1/BAVARIAN.CYRUS.BUSINESS_PROFILE_ASSIGNMENT.pptx
@@ -6,17 +6,15 @@
     <p:sldMasterId id="2147483667" r:id="rId2"/>
   </p:sldMasterIdLst>
   <p:notesMasterIdLst>
-    <p:notesMasterId r:id="rId11"/>
+    <p:notesMasterId r:id="rId9"/>
   </p:notesMasterIdLst>
   <p:sldIdLst>
-    <p:sldId id="491" r:id="rId3"/>
-    <p:sldId id="502" r:id="rId4"/>
-    <p:sldId id="492" r:id="rId5"/>
-    <p:sldId id="493" r:id="rId6"/>
-    <p:sldId id="2088198109" r:id="rId7"/>
-    <p:sldId id="501" r:id="rId8"/>
-    <p:sldId id="2088198107" r:id="rId9"/>
-    <p:sldId id="2088198108" r:id="rId10"/>
+    <p:sldId id="492" r:id="rId3"/>
+    <p:sldId id="493" r:id="rId4"/>
+    <p:sldId id="2088198109" r:id="rId5"/>
+    <p:sldId id="501" r:id="rId6"/>
+    <p:sldId id="2088198107" r:id="rId7"/>
+    <p:sldId id="2088198108" r:id="rId8"/>
   </p:sldIdLst>
   <p:sldSz cx="12192000" cy="6858000"/>
   <p:notesSz cx="6858000" cy="9144000"/>
@@ -578,7 +576,7 @@
           <a:p>
             <a:fld id="{C96F2922-797C-45C2-9475-1803A9D22A0A}" type="datetimeFigureOut">
               <a:rPr lang="en-US" smtClean="0"/>
-              <a:t>8/30/2026</a:t>
+              <a:t>9/2/2026</a:t>
             </a:fld>
             <a:endParaRPr lang="en-US"/>
           </a:p>
@@ -960,7 +958,7 @@
                 <a:tabLst/>
                 <a:defRPr/>
               </a:pPr>
-              <a:t>4</a:t>
+              <a:t>2</a:t>
             </a:fld>
             <a:endParaRPr kumimoji="0" lang="en-US" sz="1200" b="0" i="0" u="none" strike="noStrike" kern="1200" cap="none" spc="0" normalizeH="0" baseline="0" noProof="0">
               <a:ln>
@@ -1070,6 +1068,330 @@
               </a:ext>
             </a:extLst>
           </p:cNvPr>
+          <p:cNvSpPr>
+            <a:spLocks noGrp="1"/>
+          </p:cNvSpPr>
+          <p:nvPr>
+            <p:ph type="sldNum" sz="quarter" idx="10"/>
+          </p:nvPr>
+        </p:nvSpPr>
+        <p:spPr/>
+        <p:txBody>
+          <a:bodyPr/>
+          <a:lstStyle/>
+          <a:p>
+            <a:pPr marL="0" marR="0" lvl="0" indent="0" algn="r" defTabSz="914400" rtl="0" eaLnBrk="1" fontAlgn="auto" latinLnBrk="0" hangingPunct="1">
+              <a:lnSpc>
+                <a:spcPct val="100000"/>
+              </a:lnSpc>
+              <a:spcBef>
+                <a:spcPts val="0"/>
+              </a:spcBef>
+              <a:spcAft>
+                <a:spcPts val="0"/>
+              </a:spcAft>
+              <a:buClrTx/>
+              <a:buSzTx/>
+              <a:buFontTx/>
+              <a:buNone/>
+              <a:tabLst/>
+              <a:defRPr/>
+            </a:pPr>
+            <a:fld id="{6CAAD981-78BF-409D-B3BA-8A6D32CEDE01}" type="slidenum">
+              <a:rPr kumimoji="0" lang="en-US" sz="1200" b="0" i="0" u="none" strike="noStrike" kern="1200" cap="none" spc="0" normalizeH="0" baseline="0" noProof="0" smtClean="0">
+                <a:ln>
+                  <a:noFill/>
+                </a:ln>
+                <a:solidFill>
+                  <a:prstClr val="black"/>
+                </a:solidFill>
+                <a:effectLst/>
+                <a:uLnTx/>
+                <a:uFillTx/>
+                <a:latin typeface="Calibri" panose="020F0502020204030204"/>
+                <a:ea typeface="+mn-ea"/>
+                <a:cs typeface="+mn-cs"/>
+              </a:rPr>
+              <a:pPr marL="0" marR="0" lvl="0" indent="0" algn="r" defTabSz="914400" rtl="0" eaLnBrk="1" fontAlgn="auto" latinLnBrk="0" hangingPunct="1">
+                <a:lnSpc>
+                  <a:spcPct val="100000"/>
+                </a:lnSpc>
+                <a:spcBef>
+                  <a:spcPts val="0"/>
+                </a:spcBef>
+                <a:spcAft>
+                  <a:spcPts val="0"/>
+                </a:spcAft>
+                <a:buClrTx/>
+                <a:buSzTx/>
+                <a:buFontTx/>
+                <a:buNone/>
+                <a:tabLst/>
+                <a:defRPr/>
+              </a:pPr>
+              <a:t>3</a:t>
+            </a:fld>
+            <a:endParaRPr kumimoji="0" lang="en-US" sz="1200" b="0" i="0" u="none" strike="noStrike" kern="1200" cap="none" spc="0" normalizeH="0" baseline="0" noProof="0">
+              <a:ln>
+                <a:noFill/>
+              </a:ln>
+              <a:solidFill>
+                <a:prstClr val="black"/>
+              </a:solidFill>
+              <a:effectLst/>
+              <a:uLnTx/>
+              <a:uFillTx/>
+              <a:latin typeface="Calibri" panose="020F0502020204030204"/>
+              <a:ea typeface="+mn-ea"/>
+              <a:cs typeface="+mn-cs"/>
+            </a:endParaRPr>
+          </a:p>
+        </p:txBody>
+      </p:sp>
+    </p:spTree>
+    <p:extLst>
+      <p:ext uri="{BB962C8B-B14F-4D97-AF65-F5344CB8AC3E}">
+        <p14:creationId xmlns:p14="http://schemas.microsoft.com/office/powerpoint/2010/main" val="633147911"/>
+      </p:ext>
+    </p:extLst>
+  </p:cSld>
+  <p:clrMapOvr>
+    <a:masterClrMapping/>
+  </p:clrMapOvr>
+</p:notes>
+</file>
+
+<file path=ppt/notesSlides/notesSlide3.xml><?xml version="1.0" encoding="utf-8"?>
+<p:notes xmlns:a="http://schemas.openxmlformats.org/drawingml/2006/main" xmlns:r="http://schemas.openxmlformats.org/officeDocument/2006/relationships" xmlns:p="http://schemas.openxmlformats.org/presentationml/2006/main">
+  <p:cSld>
+    <p:spTree>
+      <p:nvGrpSpPr>
+        <p:cNvPr id="1" name=""/>
+        <p:cNvGrpSpPr/>
+        <p:nvPr/>
+      </p:nvGrpSpPr>
+      <p:grpSpPr>
+        <a:xfrm>
+          <a:off x="0" y="0"/>
+          <a:ext cx="0" cy="0"/>
+          <a:chOff x="0" y="0"/>
+          <a:chExt cx="0" cy="0"/>
+        </a:xfrm>
+      </p:grpSpPr>
+      <p:sp>
+        <p:nvSpPr>
+          <p:cNvPr id="2" name="Slide Image Placeholder 1"/>
+          <p:cNvSpPr>
+            <a:spLocks noGrp="1" noRot="1" noChangeAspect="1"/>
+          </p:cNvSpPr>
+          <p:nvPr>
+            <p:ph type="sldImg"/>
+          </p:nvPr>
+        </p:nvSpPr>
+        <p:spPr/>
+      </p:sp>
+      <p:sp>
+        <p:nvSpPr>
+          <p:cNvPr id="3" name="Notes Placeholder 2"/>
+          <p:cNvSpPr>
+            <a:spLocks noGrp="1"/>
+          </p:cNvSpPr>
+          <p:nvPr>
+            <p:ph type="body" idx="1"/>
+          </p:nvPr>
+        </p:nvSpPr>
+        <p:spPr/>
+        <p:txBody>
+          <a:bodyPr/>
+          <a:lstStyle/>
+          <a:p>
+            <a:r>
+              <a:rPr lang="en-US"/>
+              <a:t>Complete this slide with the Business Profile assignment.  </a:t>
+            </a:r>
+          </a:p>
+        </p:txBody>
+      </p:sp>
+      <p:sp>
+        <p:nvSpPr>
+          <p:cNvPr id="4" name="Slide Number Placeholder 3"/>
+          <p:cNvSpPr>
+            <a:spLocks noGrp="1"/>
+          </p:cNvSpPr>
+          <p:nvPr>
+            <p:ph type="sldNum" sz="quarter" idx="10"/>
+          </p:nvPr>
+        </p:nvSpPr>
+        <p:spPr/>
+        <p:txBody>
+          <a:bodyPr/>
+          <a:lstStyle/>
+          <a:p>
+            <a:pPr marL="0" marR="0" lvl="0" indent="0" algn="r" defTabSz="914400" rtl="0" eaLnBrk="1" fontAlgn="auto" latinLnBrk="0" hangingPunct="1">
+              <a:lnSpc>
+                <a:spcPct val="100000"/>
+              </a:lnSpc>
+              <a:spcBef>
+                <a:spcPts val="0"/>
+              </a:spcBef>
+              <a:spcAft>
+                <a:spcPts val="0"/>
+              </a:spcAft>
+              <a:buClrTx/>
+              <a:buSzTx/>
+              <a:buFontTx/>
+              <a:buNone/>
+              <a:tabLst/>
+              <a:defRPr/>
+            </a:pPr>
+            <a:fld id="{6CAAD981-78BF-409D-B3BA-8A6D32CEDE01}" type="slidenum">
+              <a:rPr kumimoji="0" lang="en-US" sz="1200" b="0" i="0" u="none" strike="noStrike" kern="1200" cap="none" spc="0" normalizeH="0" baseline="0" noProof="0" smtClean="0">
+                <a:ln>
+                  <a:noFill/>
+                </a:ln>
+                <a:solidFill>
+                  <a:prstClr val="black"/>
+                </a:solidFill>
+                <a:effectLst/>
+                <a:uLnTx/>
+                <a:uFillTx/>
+                <a:latin typeface="Calibri" panose="020F0502020204030204"/>
+                <a:ea typeface="+mn-ea"/>
+                <a:cs typeface="+mn-cs"/>
+              </a:rPr>
+              <a:pPr marL="0" marR="0" lvl="0" indent="0" algn="r" defTabSz="914400" rtl="0" eaLnBrk="1" fontAlgn="auto" latinLnBrk="0" hangingPunct="1">
+                <a:lnSpc>
+                  <a:spcPct val="100000"/>
+                </a:lnSpc>
+                <a:spcBef>
+                  <a:spcPts val="0"/>
+                </a:spcBef>
+                <a:spcAft>
+                  <a:spcPts val="0"/>
+                </a:spcAft>
+                <a:buClrTx/>
+                <a:buSzTx/>
+                <a:buFontTx/>
+                <a:buNone/>
+                <a:tabLst/>
+                <a:defRPr/>
+              </a:pPr>
+              <a:t>4</a:t>
+            </a:fld>
+            <a:endParaRPr kumimoji="0" lang="en-US" sz="1200" b="0" i="0" u="none" strike="noStrike" kern="1200" cap="none" spc="0" normalizeH="0" baseline="0" noProof="0">
+              <a:ln>
+                <a:noFill/>
+              </a:ln>
+              <a:solidFill>
+                <a:prstClr val="black"/>
+              </a:solidFill>
+              <a:effectLst/>
+              <a:uLnTx/>
+              <a:uFillTx/>
+              <a:latin typeface="Calibri" panose="020F0502020204030204"/>
+              <a:ea typeface="+mn-ea"/>
+              <a:cs typeface="+mn-cs"/>
+            </a:endParaRPr>
+          </a:p>
+        </p:txBody>
+      </p:sp>
+    </p:spTree>
+    <p:extLst>
+      <p:ext uri="{BB962C8B-B14F-4D97-AF65-F5344CB8AC3E}">
+        <p14:creationId xmlns:p14="http://schemas.microsoft.com/office/powerpoint/2010/main" val="39232466"/>
+      </p:ext>
+    </p:extLst>
+  </p:cSld>
+  <p:clrMapOvr>
+    <a:masterClrMapping/>
+  </p:clrMapOvr>
+</p:notes>
+</file>
+
+<file path=ppt/notesSlides/notesSlide4.xml><?xml version="1.0" encoding="utf-8"?>
+<p:notes xmlns:a="http://schemas.openxmlformats.org/drawingml/2006/main" xmlns:r="http://schemas.openxmlformats.org/officeDocument/2006/relationships" xmlns:p="http://schemas.openxmlformats.org/presentationml/2006/main">
+  <p:cSld>
+    <p:spTree>
+      <p:nvGrpSpPr>
+        <p:cNvPr id="1" name=""/>
+        <p:cNvGrpSpPr/>
+        <p:nvPr/>
+      </p:nvGrpSpPr>
+      <p:grpSpPr>
+        <a:xfrm>
+          <a:off x="0" y="0"/>
+          <a:ext cx="0" cy="0"/>
+          <a:chOff x="0" y="0"/>
+          <a:chExt cx="0" cy="0"/>
+        </a:xfrm>
+      </p:grpSpPr>
+      <p:sp>
+        <p:nvSpPr>
+          <p:cNvPr id="2" name="Slide Image Placeholder 1"/>
+          <p:cNvSpPr>
+            <a:spLocks noGrp="1" noRot="1" noChangeAspect="1"/>
+          </p:cNvSpPr>
+          <p:nvPr>
+            <p:ph type="sldImg"/>
+          </p:nvPr>
+        </p:nvSpPr>
+        <p:spPr/>
+      </p:sp>
+      <p:sp>
+        <p:nvSpPr>
+          <p:cNvPr id="3" name="Notes Placeholder 2"/>
+          <p:cNvSpPr>
+            <a:spLocks noGrp="1"/>
+          </p:cNvSpPr>
+          <p:nvPr>
+            <p:ph type="body" idx="1"/>
+          </p:nvPr>
+        </p:nvSpPr>
+        <p:spPr/>
+        <p:txBody>
+          <a:bodyPr/>
+          <a:lstStyle/>
+          <a:p>
+            <a:endParaRPr lang="en-US" dirty="0"/>
+          </a:p>
+          <a:p>
+            <a:r>
+              <a:rPr lang="en-US" dirty="0"/>
+              <a:t>Broadcom WSD in Fort Collins is a hierarchical functional organization, not a flat one. Broadcom the corporation is divisional (wireless vs. other semiconductor and software businesses). Inside the Fort Collins fab, people are grouped by specialty under a General Manager and Fab Manager, with a chain of command several layers deep: GM → Fab Manager → function → group → technicians or shifts.</a:t>
+            </a:r>
+          </a:p>
+          <a:p>
+            <a:endParaRPr lang="en-US" dirty="0"/>
+          </a:p>
+          <a:p>
+            <a:r>
+              <a:rPr lang="en-US" dirty="0"/>
+              <a:t>Does this help us hit our objectives? WSD’s objectives are 24/7 output, yield/quality, and keeping up with smartphone production ramps. The functional model does support that. Each process step has an owner, first-line managers have a narrow span of control, and defects are easy to trace to a responsible group. That is how a high-volume R&amp;D fab stays accountable when the product and the process both change quickly.</a:t>
+            </a:r>
+          </a:p>
+          <a:p>
+            <a:endParaRPr lang="en-US" dirty="0"/>
+          </a:p>
+          <a:p>
+            <a:r>
+              <a:rPr lang="en-US" dirty="0"/>
+              <a:t>The tradeoff is silos. Functions get very good at their own method, so it is hard to standardize work or move a solution from one group to another. Tribal knowledge and special cases slow cross-functional work — exactly when a yield excursion or a new product needs Equipment, Yield, R&amp;D, and Supply Chain in the same room. Also, “narrow span” is true at the group level; the Fab Manager layer is actually wide (seven functions). That is the hierarchical tradeoff from class: strong specialty focus, longer chain of command, more coordination cost.</a:t>
+            </a:r>
+          </a:p>
+          <a:p>
+            <a:endParaRPr lang="en-US" dirty="0"/>
+          </a:p>
+          <a:p>
+            <a:r>
+              <a:rPr lang="en-US" dirty="0"/>
+              <a:t>Key functions. Every box on the chart exists because one wafer becomes one filter. The two I would call most critical to keeping the factory able to run are Supply Chain and Cleanroom. Supply Chain (logistics, procurement, materials) is the only reason chemicals and parts are on hand for a 24/7 line. Cleanroom (including EHS) is the only reason the facility stays up and legal. Equipment/Process, Yield, and R&amp;D are equally critical to whether the filter is worth shipping — they own process capability, defect reduction, and the technology the customer actually buys. If any of those fail, either the line stops or the design win does not hold.</a:t>
+            </a:r>
+          </a:p>
+        </p:txBody>
+      </p:sp>
+      <p:sp>
+        <p:nvSpPr>
+          <p:cNvPr id="4" name="Slide Number Placeholder 3"/>
           <p:cNvSpPr>
             <a:spLocks noGrp="1"/>
           </p:cNvSpPr>
@@ -1153,7 +1475,7 @@
     </p:spTree>
     <p:extLst>
       <p:ext uri="{BB962C8B-B14F-4D97-AF65-F5344CB8AC3E}">
-        <p14:creationId xmlns:p14="http://schemas.microsoft.com/office/powerpoint/2010/main" val="633147911"/>
+        <p14:creationId xmlns:p14="http://schemas.microsoft.com/office/powerpoint/2010/main" val="3244879573"/>
       </p:ext>
     </p:extLst>
   </p:cSld>
@@ -1163,7 +1485,7 @@
 </p:notes>
 </file>
 
-<file path=ppt/notesSlides/notesSlide3.xml><?xml version="1.0" encoding="utf-8"?>
+<file path=ppt/notesSlides/notesSlide5.xml><?xml version="1.0" encoding="utf-8"?>
 <p:notes xmlns:a="http://schemas.openxmlformats.org/drawingml/2006/main" xmlns:r="http://schemas.openxmlformats.org/officeDocument/2006/relationships" xmlns:p="http://schemas.openxmlformats.org/presentationml/2006/main">
   <p:cSld>
     <p:spTree>
@@ -1208,9 +1530,70 @@
           <a:lstStyle/>
           <a:p>
             <a:r>
-              <a:rPr lang="en-US"/>
-              <a:t>Complete this slide with the Business Profile assignment.  </a:t>
-            </a:r>
+              <a:rPr lang="en-US" dirty="0"/>
+              <a:t>Broadcom’s Wireless Semiconductor Division (WSD) in Fort Collins is a 24/7 RF-filter fab and one of the city’s largest private employers (about 1,600 people). </a:t>
+            </a:r>
+            <a:r>
+              <a:rPr lang="en-US" b="1" dirty="0"/>
+              <a:t>Stakeholders</a:t>
+            </a:r>
+            <a:r>
+              <a:rPr lang="en-US" dirty="0"/>
+              <a:t> are the groups that can affect WSD or are affected by it. They fall into internal , external, and macro levels.</a:t>
+            </a:r>
+          </a:p>
+          <a:p>
+            <a:r>
+              <a:rPr lang="en-US" b="1" dirty="0"/>
+              <a:t>Internal stakeholders</a:t>
+            </a:r>
+            <a:r>
+              <a:rPr lang="en-US" dirty="0"/>
+              <a:t>: Operators, technicians, and engineers run the cleanroom facility. Directors align the organization around capacity, yield, and capital priorities. Without the workforce The fab would not be able to produce these products. Shareholders also play as critical stakeholders as our production capabilities here in Fort Collins directly impact the value of our publicly traded stock. </a:t>
+            </a:r>
+          </a:p>
+          <a:p>
+            <a:r>
+              <a:rPr lang="en-US" b="1" dirty="0"/>
+              <a:t>External stakeholders</a:t>
+            </a:r>
+            <a:r>
+              <a:rPr lang="en-US" dirty="0"/>
+              <a:t>: Revenue is tied to the design wins and production forecasts. Our main customer Apple sets multi-year commitments for our products which allow WSD to operate and expand. Chemical and Equipment suppliers offer a flow of raw materials and hardware to be constantly consumed in a 24/7 fab. Contractors ensure we have dedicated support for facilities, maintenance, warehouse, and cleaning which is a necessary component of running a facility that employs over 1200 people. Logistic parts carrier our final products out the doors into the hands of our packaging partners where it is assembled into a final product.</a:t>
+            </a:r>
+          </a:p>
+          <a:p>
+            <a:r>
+              <a:rPr lang="en-US" b="1" dirty="0"/>
+              <a:t>Macro Stakeholders: </a:t>
+            </a:r>
+            <a:r>
+              <a:rPr lang="en-US" b="0" dirty="0"/>
+              <a:t>The City of Fort Collins is home to Broadcom, one of the largest employers in the city, and is dependent on taxes that are generated by the organization. WSD depends on permits, utilities, and </a:t>
+            </a:r>
+            <a:r>
+              <a:rPr lang="en-US" b="0" dirty="0" err="1"/>
+              <a:t>licences</a:t>
+            </a:r>
+            <a:r>
+              <a:rPr lang="en-US" b="0" dirty="0"/>
+              <a:t> to operate in the city. OSHA, EHS, and local environmental policies set strict guidelines on the usage of chemicals from cradle to grave. CSU supplies a educated workforce pipeline and local programs between CSU and Broadcom positions to stay  staffed. The environment is a critical stakeholder for WSD as we take EHS programs very seriously to ensure we meet and exceed local regulations.</a:t>
+            </a:r>
+            <a:r>
+              <a:rPr lang="en-US" b="1" dirty="0"/>
+              <a:t> </a:t>
+            </a:r>
+          </a:p>
+          <a:p>
+            <a:r>
+              <a:rPr lang="en-US" b="1" dirty="0"/>
+              <a:t>Competitors: </a:t>
+            </a:r>
+            <a:r>
+              <a:rPr lang="en-US" b="0" dirty="0"/>
+              <a:t>Although not directly tied to our production capabilities, competitors like Qorvo and Qualcomm’s roadmaps and pricing have an impact on our products, price, placement and promotions.  </a:t>
+            </a:r>
+            <a:endParaRPr lang="en-US" b="1" dirty="0"/>
           </a:p>
         </p:txBody>
       </p:sp>
@@ -1279,391 +1662,6 @@
                 <a:defRPr/>
               </a:pPr>
               <a:t>6</a:t>
-            </a:fld>
-            <a:endParaRPr kumimoji="0" lang="en-US" sz="1200" b="0" i="0" u="none" strike="noStrike" kern="1200" cap="none" spc="0" normalizeH="0" baseline="0" noProof="0">
-              <a:ln>
-                <a:noFill/>
-              </a:ln>
-              <a:solidFill>
-                <a:prstClr val="black"/>
-              </a:solidFill>
-              <a:effectLst/>
-              <a:uLnTx/>
-              <a:uFillTx/>
-              <a:latin typeface="Calibri" panose="020F0502020204030204"/>
-              <a:ea typeface="+mn-ea"/>
-              <a:cs typeface="+mn-cs"/>
-            </a:endParaRPr>
-          </a:p>
-        </p:txBody>
-      </p:sp>
-    </p:spTree>
-    <p:extLst>
-      <p:ext uri="{BB962C8B-B14F-4D97-AF65-F5344CB8AC3E}">
-        <p14:creationId xmlns:p14="http://schemas.microsoft.com/office/powerpoint/2010/main" val="39232466"/>
-      </p:ext>
-    </p:extLst>
-  </p:cSld>
-  <p:clrMapOvr>
-    <a:masterClrMapping/>
-  </p:clrMapOvr>
-</p:notes>
-</file>
-
-<file path=ppt/notesSlides/notesSlide4.xml><?xml version="1.0" encoding="utf-8"?>
-<p:notes xmlns:a="http://schemas.openxmlformats.org/drawingml/2006/main" xmlns:r="http://schemas.openxmlformats.org/officeDocument/2006/relationships" xmlns:p="http://schemas.openxmlformats.org/presentationml/2006/main">
-  <p:cSld>
-    <p:spTree>
-      <p:nvGrpSpPr>
-        <p:cNvPr id="1" name=""/>
-        <p:cNvGrpSpPr/>
-        <p:nvPr/>
-      </p:nvGrpSpPr>
-      <p:grpSpPr>
-        <a:xfrm>
-          <a:off x="0" y="0"/>
-          <a:ext cx="0" cy="0"/>
-          <a:chOff x="0" y="0"/>
-          <a:chExt cx="0" cy="0"/>
-        </a:xfrm>
-      </p:grpSpPr>
-      <p:sp>
-        <p:nvSpPr>
-          <p:cNvPr id="2" name="Slide Image Placeholder 1"/>
-          <p:cNvSpPr>
-            <a:spLocks noGrp="1" noRot="1" noChangeAspect="1"/>
-          </p:cNvSpPr>
-          <p:nvPr>
-            <p:ph type="sldImg"/>
-          </p:nvPr>
-        </p:nvSpPr>
-        <p:spPr/>
-      </p:sp>
-      <p:sp>
-        <p:nvSpPr>
-          <p:cNvPr id="3" name="Notes Placeholder 2"/>
-          <p:cNvSpPr>
-            <a:spLocks noGrp="1"/>
-          </p:cNvSpPr>
-          <p:nvPr>
-            <p:ph type="body" idx="1"/>
-          </p:nvPr>
-        </p:nvSpPr>
-        <p:spPr/>
-        <p:txBody>
-          <a:bodyPr/>
-          <a:lstStyle/>
-          <a:p>
-            <a:endParaRPr lang="en-US" dirty="0"/>
-          </a:p>
-          <a:p>
-            <a:r>
-              <a:rPr lang="en-US" dirty="0"/>
-              <a:t>Broadcom WSD in Fort Collins is a hierarchical functional organization, not a flat one. Broadcom the corporation is divisional (wireless vs. other semiconductor and software businesses). Inside the Fort Collins fab, people are grouped by specialty under a General Manager and Fab Manager, with a chain of command several layers deep: GM → Fab Manager → function → group → technicians or shifts.</a:t>
-            </a:r>
-          </a:p>
-          <a:p>
-            <a:endParaRPr lang="en-US" dirty="0"/>
-          </a:p>
-          <a:p>
-            <a:r>
-              <a:rPr lang="en-US" dirty="0"/>
-              <a:t>Does this help us hit our objectives? WSD’s objectives are 24/7 output, yield/quality, and keeping up with smartphone production ramps. The functional model does support that. Each process step has an owner, first-line managers have a narrow span of control, and defects are easy to trace to a responsible group. That is how a high-volume R&amp;D fab stays accountable when the product and the process both change quickly.</a:t>
-            </a:r>
-          </a:p>
-          <a:p>
-            <a:endParaRPr lang="en-US" dirty="0"/>
-          </a:p>
-          <a:p>
-            <a:r>
-              <a:rPr lang="en-US" dirty="0"/>
-              <a:t>The tradeoff is silos. Functions get very good at their own method, so it is hard to standardize work or move a solution from one group to another. Tribal knowledge and special cases slow cross-functional work — exactly when a yield excursion or a new product needs Equipment, Yield, R&amp;D, and Supply Chain in the same room. Also, “narrow span” is true at the group level; the Fab Manager layer is actually wide (seven functions). That is the hierarchical tradeoff from class: strong specialty focus, longer chain of command, more coordination cost.</a:t>
-            </a:r>
-          </a:p>
-          <a:p>
-            <a:endParaRPr lang="en-US" dirty="0"/>
-          </a:p>
-          <a:p>
-            <a:r>
-              <a:rPr lang="en-US" dirty="0"/>
-              <a:t>Key functions. Every box on the chart exists because one wafer becomes one filter. The two I would call most critical to keeping the factory able to run are Supply Chain and Cleanroom. Supply Chain (logistics, procurement, materials) is the only reason chemicals and parts are on hand for a 24/7 line. Cleanroom (including EHS) is the only reason the facility stays up and legal. Equipment/Process, Yield, and R&amp;D are equally critical to whether the filter is worth shipping — they own process capability, defect reduction, and the technology the customer actually buys. If any of those fail, either the line stops or the design win does not hold.</a:t>
-            </a:r>
-          </a:p>
-        </p:txBody>
-      </p:sp>
-      <p:sp>
-        <p:nvSpPr>
-          <p:cNvPr id="4" name="Slide Number Placeholder 3"/>
-          <p:cNvSpPr>
-            <a:spLocks noGrp="1"/>
-          </p:cNvSpPr>
-          <p:nvPr>
-            <p:ph type="sldNum" sz="quarter" idx="10"/>
-          </p:nvPr>
-        </p:nvSpPr>
-        <p:spPr/>
-        <p:txBody>
-          <a:bodyPr/>
-          <a:lstStyle/>
-          <a:p>
-            <a:pPr marL="0" marR="0" lvl="0" indent="0" algn="r" defTabSz="914400" rtl="0" eaLnBrk="1" fontAlgn="auto" latinLnBrk="0" hangingPunct="1">
-              <a:lnSpc>
-                <a:spcPct val="100000"/>
-              </a:lnSpc>
-              <a:spcBef>
-                <a:spcPts val="0"/>
-              </a:spcBef>
-              <a:spcAft>
-                <a:spcPts val="0"/>
-              </a:spcAft>
-              <a:buClrTx/>
-              <a:buSzTx/>
-              <a:buFontTx/>
-              <a:buNone/>
-              <a:tabLst/>
-              <a:defRPr/>
-            </a:pPr>
-            <a:fld id="{6CAAD981-78BF-409D-B3BA-8A6D32CEDE01}" type="slidenum">
-              <a:rPr kumimoji="0" lang="en-US" sz="1200" b="0" i="0" u="none" strike="noStrike" kern="1200" cap="none" spc="0" normalizeH="0" baseline="0" noProof="0" smtClean="0">
-                <a:ln>
-                  <a:noFill/>
-                </a:ln>
-                <a:solidFill>
-                  <a:prstClr val="black"/>
-                </a:solidFill>
-                <a:effectLst/>
-                <a:uLnTx/>
-                <a:uFillTx/>
-                <a:latin typeface="Calibri" panose="020F0502020204030204"/>
-                <a:ea typeface="+mn-ea"/>
-                <a:cs typeface="+mn-cs"/>
-              </a:rPr>
-              <a:pPr marL="0" marR="0" lvl="0" indent="0" algn="r" defTabSz="914400" rtl="0" eaLnBrk="1" fontAlgn="auto" latinLnBrk="0" hangingPunct="1">
-                <a:lnSpc>
-                  <a:spcPct val="100000"/>
-                </a:lnSpc>
-                <a:spcBef>
-                  <a:spcPts val="0"/>
-                </a:spcBef>
-                <a:spcAft>
-                  <a:spcPts val="0"/>
-                </a:spcAft>
-                <a:buClrTx/>
-                <a:buSzTx/>
-                <a:buFontTx/>
-                <a:buNone/>
-                <a:tabLst/>
-                <a:defRPr/>
-              </a:pPr>
-              <a:t>7</a:t>
-            </a:fld>
-            <a:endParaRPr kumimoji="0" lang="en-US" sz="1200" b="0" i="0" u="none" strike="noStrike" kern="1200" cap="none" spc="0" normalizeH="0" baseline="0" noProof="0">
-              <a:ln>
-                <a:noFill/>
-              </a:ln>
-              <a:solidFill>
-                <a:prstClr val="black"/>
-              </a:solidFill>
-              <a:effectLst/>
-              <a:uLnTx/>
-              <a:uFillTx/>
-              <a:latin typeface="Calibri" panose="020F0502020204030204"/>
-              <a:ea typeface="+mn-ea"/>
-              <a:cs typeface="+mn-cs"/>
-            </a:endParaRPr>
-          </a:p>
-        </p:txBody>
-      </p:sp>
-    </p:spTree>
-    <p:extLst>
-      <p:ext uri="{BB962C8B-B14F-4D97-AF65-F5344CB8AC3E}">
-        <p14:creationId xmlns:p14="http://schemas.microsoft.com/office/powerpoint/2010/main" val="3244879573"/>
-      </p:ext>
-    </p:extLst>
-  </p:cSld>
-  <p:clrMapOvr>
-    <a:masterClrMapping/>
-  </p:clrMapOvr>
-</p:notes>
-</file>
-
-<file path=ppt/notesSlides/notesSlide5.xml><?xml version="1.0" encoding="utf-8"?>
-<p:notes xmlns:a="http://schemas.openxmlformats.org/drawingml/2006/main" xmlns:r="http://schemas.openxmlformats.org/officeDocument/2006/relationships" xmlns:p="http://schemas.openxmlformats.org/presentationml/2006/main">
-  <p:cSld>
-    <p:spTree>
-      <p:nvGrpSpPr>
-        <p:cNvPr id="1" name=""/>
-        <p:cNvGrpSpPr/>
-        <p:nvPr/>
-      </p:nvGrpSpPr>
-      <p:grpSpPr>
-        <a:xfrm>
-          <a:off x="0" y="0"/>
-          <a:ext cx="0" cy="0"/>
-          <a:chOff x="0" y="0"/>
-          <a:chExt cx="0" cy="0"/>
-        </a:xfrm>
-      </p:grpSpPr>
-      <p:sp>
-        <p:nvSpPr>
-          <p:cNvPr id="2" name="Slide Image Placeholder 1"/>
-          <p:cNvSpPr>
-            <a:spLocks noGrp="1" noRot="1" noChangeAspect="1"/>
-          </p:cNvSpPr>
-          <p:nvPr>
-            <p:ph type="sldImg"/>
-          </p:nvPr>
-        </p:nvSpPr>
-        <p:spPr/>
-      </p:sp>
-      <p:sp>
-        <p:nvSpPr>
-          <p:cNvPr id="3" name="Notes Placeholder 2"/>
-          <p:cNvSpPr>
-            <a:spLocks noGrp="1"/>
-          </p:cNvSpPr>
-          <p:nvPr>
-            <p:ph type="body" idx="1"/>
-          </p:nvPr>
-        </p:nvSpPr>
-        <p:spPr/>
-        <p:txBody>
-          <a:bodyPr/>
-          <a:lstStyle/>
-          <a:p>
-            <a:r>
-              <a:rPr lang="en-US" dirty="0"/>
-              <a:t>Broadcom’s Wireless Semiconductor Division (WSD) in Fort Collins is a 24/7 RF-filter fab and one of the city’s largest private employers (about 1,600 people). </a:t>
-            </a:r>
-            <a:r>
-              <a:rPr lang="en-US" b="1" dirty="0"/>
-              <a:t>Stakeholders</a:t>
-            </a:r>
-            <a:r>
-              <a:rPr lang="en-US" dirty="0"/>
-              <a:t> are the groups that can affect WSD or are affected by it. They fall into internal , external, and macro levels.</a:t>
-            </a:r>
-          </a:p>
-          <a:p>
-            <a:r>
-              <a:rPr lang="en-US" b="1" dirty="0"/>
-              <a:t>Internal stakeholders</a:t>
-            </a:r>
-            <a:r>
-              <a:rPr lang="en-US" dirty="0"/>
-              <a:t>: Operators, technicians, and engineers run the cleanroom facility. Directors align the organization around capacity, yield, and capital priorities. Without the workforce The fab would not be able to produce these products. Shareholders also play as critical stakeholders as our production capabilities here in Fort Collins directly impact the value of our publicly traded stock. </a:t>
-            </a:r>
-          </a:p>
-          <a:p>
-            <a:r>
-              <a:rPr lang="en-US" b="1" dirty="0"/>
-              <a:t>External stakeholders</a:t>
-            </a:r>
-            <a:r>
-              <a:rPr lang="en-US" dirty="0"/>
-              <a:t>: Revenue is tied to the design wins and production forecasts. Our main customer Apple sets multi-year commitments for our products which allow WSD to operate and expand. Chemical and Equipment suppliers offer a flow of raw materials and hardware to be constantly consumed in a 24/7 fab. Contractors ensure we have dedicated support for facilities, maintenance, warehouse, and cleaning which is a necessary component of running a facility that employs over 1200 people. Logistic parts carrier our final products out the doors into the hands of our packaging partners where it is assembled into a final product.</a:t>
-            </a:r>
-          </a:p>
-          <a:p>
-            <a:r>
-              <a:rPr lang="en-US" b="1" dirty="0"/>
-              <a:t>Macro Stakeholders: </a:t>
-            </a:r>
-            <a:r>
-              <a:rPr lang="en-US" b="0" dirty="0"/>
-              <a:t>The City of Fort Collins is home to Broadcom, one of the largest employers in the city, and is dependent on taxes that are generated by the organization. WSD depends on permits, utilities, and </a:t>
-            </a:r>
-            <a:r>
-              <a:rPr lang="en-US" b="0" dirty="0" err="1"/>
-              <a:t>licences</a:t>
-            </a:r>
-            <a:r>
-              <a:rPr lang="en-US" b="0" dirty="0"/>
-              <a:t> to operate in the city. OSHA, EHS, and local environmental policies set strict guidelines on the usage of chemicals from cradle to grave. CSU supplies a educated workforce pipeline and local programs between CSU and Broadcom positions to stay  staffed. The environment is a critical stakeholder for WSD as we take EHS programs very seriously to ensure we meet and exceed local regulations.</a:t>
-            </a:r>
-            <a:r>
-              <a:rPr lang="en-US" b="1" dirty="0"/>
-              <a:t> </a:t>
-            </a:r>
-          </a:p>
-          <a:p>
-            <a:r>
-              <a:rPr lang="en-US" b="1" dirty="0"/>
-              <a:t>Competitors: </a:t>
-            </a:r>
-            <a:r>
-              <a:rPr lang="en-US" b="0" dirty="0"/>
-              <a:t>Although not directly tied to our production capabilities, competitors like Qorvo and Qualcomm’s roadmaps and pricing have an impact on our products, price, placement and promotions.  </a:t>
-            </a:r>
-            <a:endParaRPr lang="en-US" b="1" dirty="0"/>
-          </a:p>
-        </p:txBody>
-      </p:sp>
-      <p:sp>
-        <p:nvSpPr>
-          <p:cNvPr id="4" name="Slide Number Placeholder 3"/>
-          <p:cNvSpPr>
-            <a:spLocks noGrp="1"/>
-          </p:cNvSpPr>
-          <p:nvPr>
-            <p:ph type="sldNum" sz="quarter" idx="10"/>
-          </p:nvPr>
-        </p:nvSpPr>
-        <p:spPr/>
-        <p:txBody>
-          <a:bodyPr/>
-          <a:lstStyle/>
-          <a:p>
-            <a:pPr marL="0" marR="0" lvl="0" indent="0" algn="r" defTabSz="914400" rtl="0" eaLnBrk="1" fontAlgn="auto" latinLnBrk="0" hangingPunct="1">
-              <a:lnSpc>
-                <a:spcPct val="100000"/>
-              </a:lnSpc>
-              <a:spcBef>
-                <a:spcPts val="0"/>
-              </a:spcBef>
-              <a:spcAft>
-                <a:spcPts val="0"/>
-              </a:spcAft>
-              <a:buClrTx/>
-              <a:buSzTx/>
-              <a:buFontTx/>
-              <a:buNone/>
-              <a:tabLst/>
-              <a:defRPr/>
-            </a:pPr>
-            <a:fld id="{6CAAD981-78BF-409D-B3BA-8A6D32CEDE01}" type="slidenum">
-              <a:rPr kumimoji="0" lang="en-US" sz="1200" b="0" i="0" u="none" strike="noStrike" kern="1200" cap="none" spc="0" normalizeH="0" baseline="0" noProof="0" smtClean="0">
-                <a:ln>
-                  <a:noFill/>
-                </a:ln>
-                <a:solidFill>
-                  <a:prstClr val="black"/>
-                </a:solidFill>
-                <a:effectLst/>
-                <a:uLnTx/>
-                <a:uFillTx/>
-                <a:latin typeface="Calibri" panose="020F0502020204030204"/>
-                <a:ea typeface="+mn-ea"/>
-                <a:cs typeface="+mn-cs"/>
-              </a:rPr>
-              <a:pPr marL="0" marR="0" lvl="0" indent="0" algn="r" defTabSz="914400" rtl="0" eaLnBrk="1" fontAlgn="auto" latinLnBrk="0" hangingPunct="1">
-                <a:lnSpc>
-                  <a:spcPct val="100000"/>
-                </a:lnSpc>
-                <a:spcBef>
-                  <a:spcPts val="0"/>
-                </a:spcBef>
-                <a:spcAft>
-                  <a:spcPts val="0"/>
-                </a:spcAft>
-                <a:buClrTx/>
-                <a:buSzTx/>
-                <a:buFontTx/>
-                <a:buNone/>
-                <a:tabLst/>
-                <a:defRPr/>
-              </a:pPr>
-              <a:t>8</a:t>
             </a:fld>
             <a:endParaRPr kumimoji="0" lang="en-US" sz="1200" b="0" i="0" u="none" strike="noStrike" kern="1200" cap="none" spc="0" normalizeH="0" baseline="0" noProof="0">
               <a:ln>
@@ -4181,1759 +4179,6 @@
           <p:cNvPr id="2" name="Title 1">
             <a:extLst>
               <a:ext uri="{FF2B5EF4-FFF2-40B4-BE49-F238E27FC236}">
-                <a16:creationId xmlns:a16="http://schemas.microsoft.com/office/drawing/2014/main" id="{4D1BE079-E601-4C76-BE39-9EECF0DD54F1}"/>
-              </a:ext>
-            </a:extLst>
-          </p:cNvPr>
-          <p:cNvSpPr>
-            <a:spLocks noGrp="1"/>
-          </p:cNvSpPr>
-          <p:nvPr>
-            <p:ph type="title"/>
-          </p:nvPr>
-        </p:nvSpPr>
-        <p:spPr/>
-        <p:txBody>
-          <a:bodyPr/>
-          <a:lstStyle/>
-          <a:p>
-            <a:r>
-              <a:rPr lang="en-US" dirty="0"/>
-              <a:t>Business Profile Assignment (BPA) Instructions</a:t>
-            </a:r>
-          </a:p>
-        </p:txBody>
-      </p:sp>
-      <p:sp>
-        <p:nvSpPr>
-          <p:cNvPr id="3" name="Content Placeholder 2">
-            <a:extLst>
-              <a:ext uri="{FF2B5EF4-FFF2-40B4-BE49-F238E27FC236}">
-                <a16:creationId xmlns:a16="http://schemas.microsoft.com/office/drawing/2014/main" id="{ADDCF111-9D3D-456A-8EA0-07182249C513}"/>
-              </a:ext>
-            </a:extLst>
-          </p:cNvPr>
-          <p:cNvSpPr>
-            <a:spLocks noGrp="1"/>
-          </p:cNvSpPr>
-          <p:nvPr>
-            <p:ph idx="1"/>
-          </p:nvPr>
-        </p:nvSpPr>
-        <p:spPr>
-          <a:xfrm>
-            <a:off x="319454" y="1077491"/>
-            <a:ext cx="11620500" cy="4351338"/>
-          </a:xfrm>
-        </p:spPr>
-        <p:txBody>
-          <a:bodyPr>
-            <a:noAutofit/>
-          </a:bodyPr>
-          <a:lstStyle/>
-          <a:p>
-            <a:pPr marL="0" indent="0">
-              <a:buNone/>
-            </a:pPr>
-            <a:r>
-              <a:rPr lang="en-US" sz="1800" dirty="0">
-                <a:latin typeface="Arial" panose="020B0604020202020204" pitchFamily="34" charset="0"/>
-                <a:cs typeface="Arial" panose="020B0604020202020204" pitchFamily="34" charset="0"/>
-              </a:rPr>
-              <a:t>You will use this deck for this template for this week’s assignment. You will turn in this PowerPoint file as your homework submission. With each subsequent assignment, please include the “Student Name” and “Business Profile – Overview” slides with your submission. Here are some points to remember when using this template:</a:t>
-            </a:r>
-          </a:p>
-          <a:p>
-            <a:r>
-              <a:rPr lang="en-US" sz="1800" dirty="0">
-                <a:latin typeface="Arial" panose="020B0604020202020204" pitchFamily="34" charset="0"/>
-                <a:cs typeface="Arial" panose="020B0604020202020204" pitchFamily="34" charset="0"/>
-              </a:rPr>
-              <a:t>You must use the same company for all assignments. Preferably, this is the company you currently work for.  However, if you are not working at the moment, or your company just doesn’t work well for these assignments (i.e. government agencies, small volunteer organizations) then select a company in an industry that interests you or that you would like to work for.</a:t>
-            </a:r>
-          </a:p>
-          <a:p>
-            <a:r>
-              <a:rPr lang="en-US" sz="1800" dirty="0">
-                <a:latin typeface="Arial" panose="020B0604020202020204" pitchFamily="34" charset="0"/>
-                <a:cs typeface="Arial" panose="020B0604020202020204" pitchFamily="34" charset="0"/>
-              </a:rPr>
-              <a:t>These assignments are built around the company you work for to maximize your ability to apply the content to a familiar context.  However, it’s a challenge for ICs that may not be as familiar with your organization.  Provide additional detail, additional notes, or anything else that can help your IC grade the assignment either in slide notes or in additional slides.</a:t>
-            </a:r>
-          </a:p>
-          <a:p>
-            <a:r>
-              <a:rPr lang="en-US" sz="1800" dirty="0">
-                <a:latin typeface="Arial" panose="020B0604020202020204" pitchFamily="34" charset="0"/>
-                <a:cs typeface="Arial" panose="020B0604020202020204" pitchFamily="34" charset="0"/>
-              </a:rPr>
-              <a:t>There are notes on each slide indicating which assignment that slide is a part of to make it easy for you to know when each slide needs to be completed.  The slide notes may also contain additional instructions – make sure you read them!</a:t>
-            </a:r>
-          </a:p>
-          <a:p>
-            <a:r>
-              <a:rPr lang="en-US" sz="1800" dirty="0">
-                <a:latin typeface="Arial" panose="020B0604020202020204" pitchFamily="34" charset="0"/>
-                <a:cs typeface="Arial" panose="020B0604020202020204" pitchFamily="34" charset="0"/>
-              </a:rPr>
-              <a:t>If additional space is necessary, you may insert additional slides and/or use the notes option, just make it clear to your IC that the content is continued on the next slide.</a:t>
-            </a:r>
-          </a:p>
-          <a:p>
-            <a:pPr marL="0" indent="0">
-              <a:buNone/>
-            </a:pPr>
-            <a:r>
-              <a:rPr lang="en-US" sz="1800" b="1" dirty="0">
-                <a:latin typeface="Arial" panose="020B0604020202020204" pitchFamily="34" charset="0"/>
-                <a:cs typeface="Arial" panose="020B0604020202020204" pitchFamily="34" charset="0"/>
-              </a:rPr>
-              <a:t>FILE NAMING</a:t>
-            </a:r>
-            <a:endParaRPr lang="en-US" sz="1800" dirty="0">
-              <a:latin typeface="Arial" panose="020B0604020202020204" pitchFamily="34" charset="0"/>
-              <a:cs typeface="Arial" panose="020B0604020202020204" pitchFamily="34" charset="0"/>
-            </a:endParaRPr>
-          </a:p>
-          <a:p>
-            <a:r>
-              <a:rPr lang="en-US" sz="1800" dirty="0">
-                <a:latin typeface="Arial" panose="020B0604020202020204" pitchFamily="34" charset="0"/>
-                <a:cs typeface="Arial" panose="020B0604020202020204" pitchFamily="34" charset="0"/>
-              </a:rPr>
-              <a:t>Please follow the file naming convention below.  This helps your IC find your assignment easily: LASTNAME.FIRSTNAME.ASSIGNMENTNAME. Example: PORTER.MICHAEL.BPA</a:t>
-            </a:r>
-          </a:p>
-          <a:p>
-            <a:pPr marL="0" indent="0">
-              <a:buNone/>
-            </a:pPr>
-            <a:r>
-              <a:rPr lang="en-US" sz="1800" dirty="0">
-                <a:latin typeface="Arial" panose="020B0604020202020204" pitchFamily="34" charset="0"/>
-                <a:cs typeface="Arial" panose="020B0604020202020204" pitchFamily="34" charset="0"/>
-              </a:rPr>
-              <a:t>  </a:t>
-            </a:r>
-          </a:p>
-        </p:txBody>
-      </p:sp>
-    </p:spTree>
-    <p:extLst>
-      <p:ext uri="{BB962C8B-B14F-4D97-AF65-F5344CB8AC3E}">
-        <p14:creationId xmlns:p14="http://schemas.microsoft.com/office/powerpoint/2010/main" val="323035411"/>
-      </p:ext>
-    </p:extLst>
-  </p:cSld>
-  <p:clrMapOvr>
-    <a:masterClrMapping/>
-  </p:clrMapOvr>
-</p:sld>
-</file>
-
-<file path=ppt/slides/slide2.xml><?xml version="1.0" encoding="utf-8"?>
-<p:sld xmlns:a="http://schemas.openxmlformats.org/drawingml/2006/main" xmlns:r="http://schemas.openxmlformats.org/officeDocument/2006/relationships" xmlns:p="http://schemas.openxmlformats.org/presentationml/2006/main">
-  <p:cSld>
-    <p:spTree>
-      <p:nvGrpSpPr>
-        <p:cNvPr id="1" name=""/>
-        <p:cNvGrpSpPr/>
-        <p:nvPr/>
-      </p:nvGrpSpPr>
-      <p:grpSpPr>
-        <a:xfrm>
-          <a:off x="0" y="0"/>
-          <a:ext cx="0" cy="0"/>
-          <a:chOff x="0" y="0"/>
-          <a:chExt cx="0" cy="0"/>
-        </a:xfrm>
-      </p:grpSpPr>
-      <p:sp>
-        <p:nvSpPr>
-          <p:cNvPr id="2" name="Title 1">
-            <a:extLst>
-              <a:ext uri="{FF2B5EF4-FFF2-40B4-BE49-F238E27FC236}">
-                <a16:creationId xmlns:a16="http://schemas.microsoft.com/office/drawing/2014/main" id="{4D1BE079-E601-4C76-BE39-9EECF0DD54F1}"/>
-              </a:ext>
-            </a:extLst>
-          </p:cNvPr>
-          <p:cNvSpPr>
-            <a:spLocks noGrp="1"/>
-          </p:cNvSpPr>
-          <p:nvPr>
-            <p:ph type="title"/>
-          </p:nvPr>
-        </p:nvSpPr>
-        <p:spPr/>
-        <p:txBody>
-          <a:bodyPr/>
-          <a:lstStyle/>
-          <a:p>
-            <a:r>
-              <a:rPr lang="en-US"/>
-              <a:t>Assignment Grading Criteria</a:t>
-            </a:r>
-          </a:p>
-        </p:txBody>
-      </p:sp>
-      <p:graphicFrame>
-        <p:nvGraphicFramePr>
-          <p:cNvPr id="8" name="Table 7">
-            <a:extLst>
-              <a:ext uri="{FF2B5EF4-FFF2-40B4-BE49-F238E27FC236}">
-                <a16:creationId xmlns:a16="http://schemas.microsoft.com/office/drawing/2014/main" id="{109D9E67-73BA-135C-15F0-5744BA094DCA}"/>
-              </a:ext>
-            </a:extLst>
-          </p:cNvPr>
-          <p:cNvGraphicFramePr>
-            <a:graphicFrameLocks noGrp="1"/>
-          </p:cNvGraphicFramePr>
-          <p:nvPr/>
-        </p:nvGraphicFramePr>
-        <p:xfrm>
-          <a:off x="248607" y="1549744"/>
-          <a:ext cx="6029101" cy="4040173"/>
-        </p:xfrm>
-        <a:graphic>
-          <a:graphicData uri="http://schemas.openxmlformats.org/drawingml/2006/table">
-            <a:tbl>
-              <a:tblPr/>
-              <a:tblGrid>
-                <a:gridCol w="4921270">
-                  <a:extLst>
-                    <a:ext uri="{9D8B030D-6E8A-4147-A177-3AD203B41FA5}">
-                      <a16:colId xmlns:a16="http://schemas.microsoft.com/office/drawing/2014/main" val="2945378647"/>
-                    </a:ext>
-                  </a:extLst>
-                </a:gridCol>
-                <a:gridCol w="1107831">
-                  <a:extLst>
-                    <a:ext uri="{9D8B030D-6E8A-4147-A177-3AD203B41FA5}">
-                      <a16:colId xmlns:a16="http://schemas.microsoft.com/office/drawing/2014/main" val="45585094"/>
-                    </a:ext>
-                  </a:extLst>
-                </a:gridCol>
-              </a:tblGrid>
-              <a:tr h="64915">
-                <a:tc gridSpan="2">
-                  <a:txBody>
-                    <a:bodyPr/>
-                    <a:lstStyle/>
-                    <a:p>
-                      <a:pPr algn="ctr"/>
-                      <a:r>
-                        <a:rPr lang="en-US" sz="1800" b="1" dirty="0"/>
-                        <a:t>Business Profile Assignment Rubric</a:t>
-                      </a:r>
-                    </a:p>
-                  </a:txBody>
-                  <a:tcPr marL="16229" marR="16229" marT="8114" marB="8114" anchor="ctr">
-                    <a:lnL w="12700" cap="flat" cmpd="sng" algn="ctr">
-                      <a:solidFill>
-                        <a:schemeClr val="tx1"/>
-                      </a:solidFill>
-                      <a:prstDash val="solid"/>
-                      <a:round/>
-                      <a:headEnd type="none" w="med" len="med"/>
-                      <a:tailEnd type="none" w="med" len="med"/>
-                    </a:lnL>
-                    <a:lnR w="12700" cap="flat" cmpd="sng" algn="ctr">
-                      <a:solidFill>
-                        <a:schemeClr val="tx1"/>
-                      </a:solidFill>
-                      <a:prstDash val="solid"/>
-                      <a:round/>
-                      <a:headEnd type="none" w="med" len="med"/>
-                      <a:tailEnd type="none" w="med" len="med"/>
-                    </a:lnR>
-                    <a:lnT w="12700" cap="flat" cmpd="sng" algn="ctr">
-                      <a:solidFill>
-                        <a:schemeClr val="tx1"/>
-                      </a:solidFill>
-                      <a:prstDash val="solid"/>
-                      <a:round/>
-                      <a:headEnd type="none" w="med" len="med"/>
-                      <a:tailEnd type="none" w="med" len="med"/>
-                    </a:lnT>
-                    <a:lnB w="12700" cap="flat" cmpd="sng" algn="ctr">
-                      <a:solidFill>
-                        <a:schemeClr val="tx1"/>
-                      </a:solidFill>
-                      <a:prstDash val="solid"/>
-                      <a:round/>
-                      <a:headEnd type="none" w="med" len="med"/>
-                      <a:tailEnd type="none" w="med" len="med"/>
-                    </a:lnB>
-                    <a:solidFill>
-                      <a:srgbClr val="FFFFFF"/>
-                    </a:solidFill>
-                  </a:tcPr>
-                </a:tc>
-                <a:tc hMerge="1">
-                  <a:txBody>
-                    <a:bodyPr/>
-                    <a:lstStyle/>
-                    <a:p>
-                      <a:endParaRPr lang="en-US"/>
-                    </a:p>
-                  </a:txBody>
-                  <a:tcPr>
-                    <a:lnL w="12700" cap="flat" cmpd="sng" algn="ctr">
-                      <a:solidFill>
-                        <a:schemeClr val="tx1"/>
-                      </a:solidFill>
-                      <a:prstDash val="solid"/>
-                      <a:round/>
-                      <a:headEnd type="none" w="med" len="med"/>
-                      <a:tailEnd type="none" w="med" len="med"/>
-                    </a:lnL>
-                  </a:tcPr>
-                </a:tc>
-                <a:extLst>
-                  <a:ext uri="{0D108BD9-81ED-4DB2-BD59-A6C34878D82A}">
-                    <a16:rowId xmlns:a16="http://schemas.microsoft.com/office/drawing/2014/main" val="173655088"/>
-                  </a:ext>
-                </a:extLst>
-              </a:tr>
-              <a:tr h="363258">
-                <a:tc>
-                  <a:txBody>
-                    <a:bodyPr/>
-                    <a:lstStyle/>
-                    <a:p>
-                      <a:pPr algn="ctr"/>
-                      <a:r>
-                        <a:rPr lang="en-US" sz="1400" b="1">
-                          <a:effectLst/>
-                          <a:highlight>
-                            <a:srgbClr val="FFFFFF"/>
-                          </a:highlight>
-                        </a:rPr>
-                        <a:t>Criteria</a:t>
-                      </a:r>
-                    </a:p>
-                  </a:txBody>
-                  <a:tcPr marL="16905" marR="16905" marT="11833" marB="11833" anchor="ctr">
-                    <a:lnL w="12700" cap="flat" cmpd="sng" algn="ctr">
-                      <a:solidFill>
-                        <a:schemeClr val="tx1"/>
-                      </a:solidFill>
-                      <a:prstDash val="solid"/>
-                      <a:round/>
-                      <a:headEnd type="none" w="med" len="med"/>
-                      <a:tailEnd type="none" w="med" len="med"/>
-                    </a:lnL>
-                    <a:lnR w="12700" cap="flat" cmpd="sng" algn="ctr">
-                      <a:solidFill>
-                        <a:schemeClr val="tx1"/>
-                      </a:solidFill>
-                      <a:prstDash val="solid"/>
-                      <a:round/>
-                      <a:headEnd type="none" w="med" len="med"/>
-                      <a:tailEnd type="none" w="med" len="med"/>
-                    </a:lnR>
-                    <a:lnT w="12700" cap="flat" cmpd="sng" algn="ctr">
-                      <a:solidFill>
-                        <a:schemeClr val="tx1"/>
-                      </a:solidFill>
-                      <a:prstDash val="solid"/>
-                      <a:round/>
-                      <a:headEnd type="none" w="med" len="med"/>
-                      <a:tailEnd type="none" w="med" len="med"/>
-                    </a:lnT>
-                    <a:lnB w="12700" cap="flat" cmpd="sng" algn="ctr">
-                      <a:solidFill>
-                        <a:schemeClr val="tx1"/>
-                      </a:solidFill>
-                      <a:prstDash val="solid"/>
-                      <a:round/>
-                      <a:headEnd type="none" w="med" len="med"/>
-                      <a:tailEnd type="none" w="med" len="med"/>
-                    </a:lnB>
-                    <a:solidFill>
-                      <a:srgbClr val="FFFFFF"/>
-                    </a:solidFill>
-                  </a:tcPr>
-                </a:tc>
-                <a:tc>
-                  <a:txBody>
-                    <a:bodyPr/>
-                    <a:lstStyle/>
-                    <a:p>
-                      <a:pPr algn="ctr"/>
-                      <a:r>
-                        <a:rPr lang="en-US" sz="1400" b="1">
-                          <a:effectLst/>
-                          <a:highlight>
-                            <a:srgbClr val="FFFFFF"/>
-                          </a:highlight>
-                        </a:rPr>
-                        <a:t>Pts</a:t>
-                      </a:r>
-                    </a:p>
-                  </a:txBody>
-                  <a:tcPr marL="16905" marR="16905" marT="11833" marB="11833" anchor="ctr">
-                    <a:lnL w="12700" cap="flat" cmpd="sng" algn="ctr">
-                      <a:solidFill>
-                        <a:schemeClr val="tx1"/>
-                      </a:solidFill>
-                      <a:prstDash val="solid"/>
-                      <a:round/>
-                      <a:headEnd type="none" w="med" len="med"/>
-                      <a:tailEnd type="none" w="med" len="med"/>
-                    </a:lnL>
-                    <a:lnR w="12700" cap="flat" cmpd="sng" algn="ctr">
-                      <a:solidFill>
-                        <a:schemeClr val="tx1"/>
-                      </a:solidFill>
-                      <a:prstDash val="solid"/>
-                      <a:round/>
-                      <a:headEnd type="none" w="med" len="med"/>
-                      <a:tailEnd type="none" w="med" len="med"/>
-                    </a:lnR>
-                    <a:lnB w="12700" cap="flat" cmpd="sng" algn="ctr">
-                      <a:solidFill>
-                        <a:schemeClr val="tx1"/>
-                      </a:solidFill>
-                      <a:prstDash val="solid"/>
-                      <a:round/>
-                      <a:headEnd type="none" w="med" len="med"/>
-                      <a:tailEnd type="none" w="med" len="med"/>
-                    </a:lnB>
-                    <a:solidFill>
-                      <a:srgbClr val="FFFFFF"/>
-                    </a:solidFill>
-                  </a:tcPr>
-                </a:tc>
-                <a:extLst>
-                  <a:ext uri="{0D108BD9-81ED-4DB2-BD59-A6C34878D82A}">
-                    <a16:rowId xmlns:a16="http://schemas.microsoft.com/office/drawing/2014/main" val="669659512"/>
-                  </a:ext>
-                </a:extLst>
-              </a:tr>
-              <a:tr h="834429">
-                <a:tc>
-                  <a:txBody>
-                    <a:bodyPr/>
-                    <a:lstStyle/>
-                    <a:p>
-                      <a:pPr fontAlgn="ctr"/>
-                      <a:r>
-                        <a:rPr lang="en-US" sz="1200" b="1">
-                          <a:effectLst/>
-                        </a:rPr>
-                        <a:t>Business Profile</a:t>
-                      </a:r>
-                    </a:p>
-                    <a:p>
-                      <a:pPr fontAlgn="ctr"/>
-                      <a:r>
-                        <a:rPr lang="en-US" sz="1200" b="0">
-                          <a:effectLst/>
-                        </a:rPr>
-                        <a:t>What’s your elevator pitch?</a:t>
-                      </a:r>
-                      <a:br>
-                        <a:rPr lang="en-US" sz="1200" b="0">
-                          <a:effectLst/>
-                        </a:rPr>
-                      </a:br>
-                      <a:r>
-                        <a:rPr lang="en-US" sz="1200" b="0">
-                          <a:effectLst/>
-                        </a:rPr>
-                        <a:t>Be sure you provide sufficient detail for your IC to understand your business.</a:t>
-                      </a:r>
-                    </a:p>
-                  </a:txBody>
-                  <a:tcPr marL="16905" marR="16905" marT="11833" marB="11833">
-                    <a:lnL w="12700" cap="flat" cmpd="sng" algn="ctr">
-                      <a:solidFill>
-                        <a:schemeClr val="tx1"/>
-                      </a:solidFill>
-                      <a:prstDash val="solid"/>
-                      <a:round/>
-                      <a:headEnd type="none" w="med" len="med"/>
-                      <a:tailEnd type="none" w="med" len="med"/>
-                    </a:lnL>
-                    <a:lnR w="12700" cap="flat" cmpd="sng" algn="ctr">
-                      <a:solidFill>
-                        <a:schemeClr val="tx1"/>
-                      </a:solidFill>
-                      <a:prstDash val="solid"/>
-                      <a:round/>
-                      <a:headEnd type="none" w="med" len="med"/>
-                      <a:tailEnd type="none" w="med" len="med"/>
-                    </a:lnR>
-                    <a:lnT w="12700" cap="flat" cmpd="sng" algn="ctr">
-                      <a:solidFill>
-                        <a:schemeClr val="tx1"/>
-                      </a:solidFill>
-                      <a:prstDash val="solid"/>
-                      <a:round/>
-                      <a:headEnd type="none" w="med" len="med"/>
-                      <a:tailEnd type="none" w="med" len="med"/>
-                    </a:lnT>
-                    <a:lnB w="12700" cap="flat" cmpd="sng" algn="ctr">
-                      <a:solidFill>
-                        <a:schemeClr val="tx1"/>
-                      </a:solidFill>
-                      <a:prstDash val="solid"/>
-                      <a:round/>
-                      <a:headEnd type="none" w="med" len="med"/>
-                      <a:tailEnd type="none" w="med" len="med"/>
-                    </a:lnB>
-                    <a:solidFill>
-                      <a:srgbClr val="FFFFFF"/>
-                    </a:solidFill>
-                  </a:tcPr>
-                </a:tc>
-                <a:tc>
-                  <a:txBody>
-                    <a:bodyPr/>
-                    <a:lstStyle/>
-                    <a:p>
-                      <a:pPr algn="ctr"/>
-                      <a:r>
-                        <a:rPr lang="en-US" sz="1400">
-                          <a:effectLst/>
-                        </a:rPr>
-                        <a:t>10 pts</a:t>
-                      </a:r>
-                      <a:br>
-                        <a:rPr lang="en-US" sz="1400">
-                          <a:effectLst/>
-                        </a:rPr>
-                      </a:br>
-                      <a:endParaRPr lang="en-US" sz="1400">
-                        <a:effectLst/>
-                      </a:endParaRPr>
-                    </a:p>
-                  </a:txBody>
-                  <a:tcPr marL="16905" marR="16905" marT="11833" marB="11833" anchor="ctr">
-                    <a:lnL w="12700" cap="flat" cmpd="sng" algn="ctr">
-                      <a:solidFill>
-                        <a:schemeClr val="tx1"/>
-                      </a:solidFill>
-                      <a:prstDash val="solid"/>
-                      <a:round/>
-                      <a:headEnd type="none" w="med" len="med"/>
-                      <a:tailEnd type="none" w="med" len="med"/>
-                    </a:lnL>
-                    <a:lnR w="12700" cap="flat" cmpd="sng" algn="ctr">
-                      <a:solidFill>
-                        <a:schemeClr val="tx1"/>
-                      </a:solidFill>
-                      <a:prstDash val="solid"/>
-                      <a:round/>
-                      <a:headEnd type="none" w="med" len="med"/>
-                      <a:tailEnd type="none" w="med" len="med"/>
-                    </a:lnR>
-                    <a:lnT w="12700" cap="flat" cmpd="sng" algn="ctr">
-                      <a:solidFill>
-                        <a:schemeClr val="tx1"/>
-                      </a:solidFill>
-                      <a:prstDash val="solid"/>
-                      <a:round/>
-                      <a:headEnd type="none" w="med" len="med"/>
-                      <a:tailEnd type="none" w="med" len="med"/>
-                    </a:lnT>
-                    <a:lnB w="12700" cap="flat" cmpd="sng" algn="ctr">
-                      <a:solidFill>
-                        <a:schemeClr val="tx1"/>
-                      </a:solidFill>
-                      <a:prstDash val="solid"/>
-                      <a:round/>
-                      <a:headEnd type="none" w="med" len="med"/>
-                      <a:tailEnd type="none" w="med" len="med"/>
-                    </a:lnB>
-                    <a:solidFill>
-                      <a:srgbClr val="FFFFFF"/>
-                    </a:solidFill>
-                  </a:tcPr>
-                </a:tc>
-                <a:extLst>
-                  <a:ext uri="{0D108BD9-81ED-4DB2-BD59-A6C34878D82A}">
-                    <a16:rowId xmlns:a16="http://schemas.microsoft.com/office/drawing/2014/main" val="3112314360"/>
-                  </a:ext>
-                </a:extLst>
-              </a:tr>
-              <a:tr h="948707">
-                <a:tc>
-                  <a:txBody>
-                    <a:bodyPr/>
-                    <a:lstStyle/>
-                    <a:p>
-                      <a:pPr fontAlgn="ctr"/>
-                      <a:r>
-                        <a:rPr lang="en-US" sz="1200" b="1">
-                          <a:effectLst/>
-                        </a:rPr>
-                        <a:t>Organization Structure</a:t>
-                      </a:r>
-                    </a:p>
-                    <a:p>
-                      <a:pPr fontAlgn="ctr"/>
-                      <a:r>
-                        <a:rPr lang="en-US" sz="1200" b="0">
-                          <a:effectLst/>
-                        </a:rPr>
-                        <a:t>Provide company organizational structure.</a:t>
-                      </a:r>
-                      <a:br>
-                        <a:rPr lang="en-US" sz="1200" b="0">
-                          <a:effectLst/>
-                        </a:rPr>
-                      </a:br>
-                      <a:r>
-                        <a:rPr lang="en-US" sz="1200" b="0">
-                          <a:effectLst/>
-                        </a:rPr>
-                        <a:t>Explain how your company is organized: is it a hierarchical organization? Flat organization?</a:t>
-                      </a:r>
-                      <a:br>
-                        <a:rPr lang="en-US" sz="1200" b="0">
-                          <a:effectLst/>
-                        </a:rPr>
-                      </a:br>
-                      <a:r>
-                        <a:rPr lang="en-US" sz="1200" b="0">
-                          <a:effectLst/>
-                        </a:rPr>
-                        <a:t>Does the organizational structure facilitate meeting your objectives? Why?</a:t>
-                      </a:r>
-                      <a:br>
-                        <a:rPr lang="en-US" sz="1200" b="0">
-                          <a:effectLst/>
-                        </a:rPr>
-                      </a:br>
-                      <a:r>
-                        <a:rPr lang="en-US" sz="1200" b="0">
-                          <a:effectLst/>
-                        </a:rPr>
-                        <a:t>Which functional areas are key to your organization’s success and why?</a:t>
-                      </a:r>
-                    </a:p>
-                  </a:txBody>
-                  <a:tcPr marL="16905" marR="16905" marT="11833" marB="11833">
-                    <a:lnL w="12700" cap="flat" cmpd="sng" algn="ctr">
-                      <a:solidFill>
-                        <a:schemeClr val="tx1"/>
-                      </a:solidFill>
-                      <a:prstDash val="solid"/>
-                      <a:round/>
-                      <a:headEnd type="none" w="med" len="med"/>
-                      <a:tailEnd type="none" w="med" len="med"/>
-                    </a:lnL>
-                    <a:lnR w="12700" cap="flat" cmpd="sng" algn="ctr">
-                      <a:solidFill>
-                        <a:schemeClr val="tx1"/>
-                      </a:solidFill>
-                      <a:prstDash val="solid"/>
-                      <a:round/>
-                      <a:headEnd type="none" w="med" len="med"/>
-                      <a:tailEnd type="none" w="med" len="med"/>
-                    </a:lnR>
-                    <a:lnT w="12700" cap="flat" cmpd="sng" algn="ctr">
-                      <a:solidFill>
-                        <a:schemeClr val="tx1"/>
-                      </a:solidFill>
-                      <a:prstDash val="solid"/>
-                      <a:round/>
-                      <a:headEnd type="none" w="med" len="med"/>
-                      <a:tailEnd type="none" w="med" len="med"/>
-                    </a:lnT>
-                    <a:lnB w="12700" cap="flat" cmpd="sng" algn="ctr">
-                      <a:solidFill>
-                        <a:schemeClr val="tx1"/>
-                      </a:solidFill>
-                      <a:prstDash val="solid"/>
-                      <a:round/>
-                      <a:headEnd type="none" w="med" len="med"/>
-                      <a:tailEnd type="none" w="med" len="med"/>
-                    </a:lnB>
-                    <a:solidFill>
-                      <a:srgbClr val="FFFFFF"/>
-                    </a:solidFill>
-                  </a:tcPr>
-                </a:tc>
-                <a:tc>
-                  <a:txBody>
-                    <a:bodyPr/>
-                    <a:lstStyle/>
-                    <a:p>
-                      <a:pPr algn="ctr"/>
-                      <a:r>
-                        <a:rPr lang="en-US" sz="1400">
-                          <a:effectLst/>
-                        </a:rPr>
-                        <a:t>35 pts</a:t>
-                      </a:r>
-                      <a:br>
-                        <a:rPr lang="en-US" sz="1400">
-                          <a:effectLst/>
-                        </a:rPr>
-                      </a:br>
-                      <a:endParaRPr lang="en-US" sz="1400">
-                        <a:effectLst/>
-                      </a:endParaRPr>
-                    </a:p>
-                  </a:txBody>
-                  <a:tcPr marL="16905" marR="16905" marT="11833" marB="11833" anchor="ctr">
-                    <a:lnL w="12700" cap="flat" cmpd="sng" algn="ctr">
-                      <a:solidFill>
-                        <a:schemeClr val="tx1"/>
-                      </a:solidFill>
-                      <a:prstDash val="solid"/>
-                      <a:round/>
-                      <a:headEnd type="none" w="med" len="med"/>
-                      <a:tailEnd type="none" w="med" len="med"/>
-                    </a:lnL>
-                    <a:lnR w="12700" cap="flat" cmpd="sng" algn="ctr">
-                      <a:solidFill>
-                        <a:schemeClr val="tx1"/>
-                      </a:solidFill>
-                      <a:prstDash val="solid"/>
-                      <a:round/>
-                      <a:headEnd type="none" w="med" len="med"/>
-                      <a:tailEnd type="none" w="med" len="med"/>
-                    </a:lnR>
-                    <a:lnT w="12700" cap="flat" cmpd="sng" algn="ctr">
-                      <a:solidFill>
-                        <a:schemeClr val="tx1"/>
-                      </a:solidFill>
-                      <a:prstDash val="solid"/>
-                      <a:round/>
-                      <a:headEnd type="none" w="med" len="med"/>
-                      <a:tailEnd type="none" w="med" len="med"/>
-                    </a:lnT>
-                    <a:lnB w="12700" cap="flat" cmpd="sng" algn="ctr">
-                      <a:solidFill>
-                        <a:schemeClr val="tx1"/>
-                      </a:solidFill>
-                      <a:prstDash val="solid"/>
-                      <a:round/>
-                      <a:headEnd type="none" w="med" len="med"/>
-                      <a:tailEnd type="none" w="med" len="med"/>
-                    </a:lnB>
-                    <a:solidFill>
-                      <a:srgbClr val="FFFFFF"/>
-                    </a:solidFill>
-                  </a:tcPr>
-                </a:tc>
-                <a:extLst>
-                  <a:ext uri="{0D108BD9-81ED-4DB2-BD59-A6C34878D82A}">
-                    <a16:rowId xmlns:a16="http://schemas.microsoft.com/office/drawing/2014/main" val="191565112"/>
-                  </a:ext>
-                </a:extLst>
-              </a:tr>
-              <a:tr h="834429">
-                <a:tc>
-                  <a:txBody>
-                    <a:bodyPr/>
-                    <a:lstStyle/>
-                    <a:p>
-                      <a:pPr fontAlgn="ctr"/>
-                      <a:r>
-                        <a:rPr lang="en-US" sz="1200" b="1">
-                          <a:effectLst/>
-                        </a:rPr>
-                        <a:t>Stakeholders</a:t>
-                      </a:r>
-                    </a:p>
-                    <a:p>
-                      <a:pPr fontAlgn="ctr"/>
-                      <a:r>
-                        <a:rPr lang="en-US" sz="1200" b="0">
-                          <a:effectLst/>
-                        </a:rPr>
-                        <a:t>Who are some of the key stakeholders for your company?</a:t>
-                      </a:r>
-                      <a:br>
-                        <a:rPr lang="en-US" sz="1200" b="0">
-                          <a:effectLst/>
-                        </a:rPr>
-                      </a:br>
-                      <a:r>
-                        <a:rPr lang="en-US" sz="1200" b="0">
-                          <a:effectLst/>
-                        </a:rPr>
-                        <a:t>What are ways that they influence your organization?</a:t>
-                      </a:r>
-                      <a:br>
-                        <a:rPr lang="en-US" sz="1200" b="0">
-                          <a:effectLst/>
-                        </a:rPr>
-                      </a:br>
-                      <a:r>
-                        <a:rPr lang="en-US" sz="1200" b="0">
-                          <a:effectLst/>
-                        </a:rPr>
-                        <a:t>What are some examples of how they are critical to your organization’s success?</a:t>
-                      </a:r>
-                    </a:p>
-                  </a:txBody>
-                  <a:tcPr marL="16905" marR="16905" marT="11833" marB="11833">
-                    <a:lnL w="12700" cap="flat" cmpd="sng" algn="ctr">
-                      <a:solidFill>
-                        <a:schemeClr val="tx1"/>
-                      </a:solidFill>
-                      <a:prstDash val="solid"/>
-                      <a:round/>
-                      <a:headEnd type="none" w="med" len="med"/>
-                      <a:tailEnd type="none" w="med" len="med"/>
-                    </a:lnL>
-                    <a:lnR w="12700" cap="flat" cmpd="sng" algn="ctr">
-                      <a:solidFill>
-                        <a:schemeClr val="tx1"/>
-                      </a:solidFill>
-                      <a:prstDash val="solid"/>
-                      <a:round/>
-                      <a:headEnd type="none" w="med" len="med"/>
-                      <a:tailEnd type="none" w="med" len="med"/>
-                    </a:lnR>
-                    <a:lnT w="12700" cap="flat" cmpd="sng" algn="ctr">
-                      <a:solidFill>
-                        <a:schemeClr val="tx1"/>
-                      </a:solidFill>
-                      <a:prstDash val="solid"/>
-                      <a:round/>
-                      <a:headEnd type="none" w="med" len="med"/>
-                      <a:tailEnd type="none" w="med" len="med"/>
-                    </a:lnT>
-                    <a:lnB w="12700" cap="flat" cmpd="sng" algn="ctr">
-                      <a:solidFill>
-                        <a:schemeClr val="tx1"/>
-                      </a:solidFill>
-                      <a:prstDash val="solid"/>
-                      <a:round/>
-                      <a:headEnd type="none" w="med" len="med"/>
-                      <a:tailEnd type="none" w="med" len="med"/>
-                    </a:lnB>
-                    <a:solidFill>
-                      <a:srgbClr val="FFFFFF"/>
-                    </a:solidFill>
-                  </a:tcPr>
-                </a:tc>
-                <a:tc>
-                  <a:txBody>
-                    <a:bodyPr/>
-                    <a:lstStyle/>
-                    <a:p>
-                      <a:pPr algn="ctr"/>
-                      <a:r>
-                        <a:rPr lang="en-US" sz="1400">
-                          <a:effectLst/>
-                        </a:rPr>
-                        <a:t>35 pts</a:t>
-                      </a:r>
-                      <a:br>
-                        <a:rPr lang="en-US" sz="1400">
-                          <a:effectLst/>
-                        </a:rPr>
-                      </a:br>
-                      <a:endParaRPr lang="en-US" sz="1400">
-                        <a:effectLst/>
-                      </a:endParaRPr>
-                    </a:p>
-                  </a:txBody>
-                  <a:tcPr marL="16905" marR="16905" marT="11833" marB="11833" anchor="ctr">
-                    <a:lnL w="12700" cap="flat" cmpd="sng" algn="ctr">
-                      <a:solidFill>
-                        <a:schemeClr val="tx1"/>
-                      </a:solidFill>
-                      <a:prstDash val="solid"/>
-                      <a:round/>
-                      <a:headEnd type="none" w="med" len="med"/>
-                      <a:tailEnd type="none" w="med" len="med"/>
-                    </a:lnL>
-                    <a:lnR w="12700" cap="flat" cmpd="sng" algn="ctr">
-                      <a:solidFill>
-                        <a:schemeClr val="tx1"/>
-                      </a:solidFill>
-                      <a:prstDash val="solid"/>
-                      <a:round/>
-                      <a:headEnd type="none" w="med" len="med"/>
-                      <a:tailEnd type="none" w="med" len="med"/>
-                    </a:lnR>
-                    <a:lnT w="12700" cap="flat" cmpd="sng" algn="ctr">
-                      <a:solidFill>
-                        <a:schemeClr val="tx1"/>
-                      </a:solidFill>
-                      <a:prstDash val="solid"/>
-                      <a:round/>
-                      <a:headEnd type="none" w="med" len="med"/>
-                      <a:tailEnd type="none" w="med" len="med"/>
-                    </a:lnT>
-                    <a:lnB w="12700" cap="flat" cmpd="sng" algn="ctr">
-                      <a:solidFill>
-                        <a:schemeClr val="tx1"/>
-                      </a:solidFill>
-                      <a:prstDash val="solid"/>
-                      <a:round/>
-                      <a:headEnd type="none" w="med" len="med"/>
-                      <a:tailEnd type="none" w="med" len="med"/>
-                    </a:lnB>
-                    <a:solidFill>
-                      <a:srgbClr val="FFFFFF"/>
-                    </a:solidFill>
-                  </a:tcPr>
-                </a:tc>
-                <a:extLst>
-                  <a:ext uri="{0D108BD9-81ED-4DB2-BD59-A6C34878D82A}">
-                    <a16:rowId xmlns:a16="http://schemas.microsoft.com/office/drawing/2014/main" val="86939744"/>
-                  </a:ext>
-                </a:extLst>
-              </a:tr>
-              <a:tr h="492926">
-                <a:tc gridSpan="2">
-                  <a:txBody>
-                    <a:bodyPr/>
-                    <a:lstStyle/>
-                    <a:p>
-                      <a:pPr algn="r"/>
-                      <a:r>
-                        <a:rPr lang="en-US" sz="1400" dirty="0">
-                          <a:effectLst/>
-                        </a:rPr>
-                        <a:t>Total Points: 80</a:t>
-                      </a:r>
-                    </a:p>
-                  </a:txBody>
-                  <a:tcPr marL="16905" marR="16905" marT="11833" marB="11833" anchor="ctr">
-                    <a:lnL w="12700" cap="flat" cmpd="sng" algn="ctr">
-                      <a:solidFill>
-                        <a:schemeClr val="tx1"/>
-                      </a:solidFill>
-                      <a:prstDash val="solid"/>
-                      <a:round/>
-                      <a:headEnd type="none" w="med" len="med"/>
-                      <a:tailEnd type="none" w="med" len="med"/>
-                    </a:lnL>
-                    <a:lnR w="12700" cap="flat" cmpd="sng" algn="ctr">
-                      <a:solidFill>
-                        <a:schemeClr val="tx1"/>
-                      </a:solidFill>
-                      <a:prstDash val="solid"/>
-                      <a:round/>
-                      <a:headEnd type="none" w="med" len="med"/>
-                      <a:tailEnd type="none" w="med" len="med"/>
-                    </a:lnR>
-                    <a:lnT w="12700" cap="flat" cmpd="sng" algn="ctr">
-                      <a:solidFill>
-                        <a:schemeClr val="tx1"/>
-                      </a:solidFill>
-                      <a:prstDash val="solid"/>
-                      <a:round/>
-                      <a:headEnd type="none" w="med" len="med"/>
-                      <a:tailEnd type="none" w="med" len="med"/>
-                    </a:lnT>
-                    <a:lnB w="12700" cap="flat" cmpd="sng" algn="ctr">
-                      <a:solidFill>
-                        <a:schemeClr val="tx1"/>
-                      </a:solidFill>
-                      <a:prstDash val="solid"/>
-                      <a:round/>
-                      <a:headEnd type="none" w="med" len="med"/>
-                      <a:tailEnd type="none" w="med" len="med"/>
-                    </a:lnB>
-                    <a:solidFill>
-                      <a:srgbClr val="FFFFFF"/>
-                    </a:solidFill>
-                  </a:tcPr>
-                </a:tc>
-                <a:tc hMerge="1">
-                  <a:txBody>
-                    <a:bodyPr/>
-                    <a:lstStyle/>
-                    <a:p>
-                      <a:endParaRPr lang="en-US"/>
-                    </a:p>
-                  </a:txBody>
-                  <a:tcPr>
-                    <a:lnL w="12700" cap="flat" cmpd="sng" algn="ctr">
-                      <a:solidFill>
-                        <a:schemeClr val="tx1"/>
-                      </a:solidFill>
-                      <a:prstDash val="solid"/>
-                      <a:round/>
-                      <a:headEnd type="none" w="med" len="med"/>
-                      <a:tailEnd type="none" w="med" len="med"/>
-                    </a:lnL>
-                    <a:lnT w="12700" cap="flat" cmpd="sng" algn="ctr">
-                      <a:solidFill>
-                        <a:schemeClr val="tx1"/>
-                      </a:solidFill>
-                      <a:prstDash val="solid"/>
-                      <a:round/>
-                      <a:headEnd type="none" w="med" len="med"/>
-                      <a:tailEnd type="none" w="med" len="med"/>
-                    </a:lnT>
-                  </a:tcPr>
-                </a:tc>
-                <a:extLst>
-                  <a:ext uri="{0D108BD9-81ED-4DB2-BD59-A6C34878D82A}">
-                    <a16:rowId xmlns:a16="http://schemas.microsoft.com/office/drawing/2014/main" val="2278457049"/>
-                  </a:ext>
-                </a:extLst>
-              </a:tr>
-            </a:tbl>
-          </a:graphicData>
-        </a:graphic>
-      </p:graphicFrame>
-      <p:sp>
-        <p:nvSpPr>
-          <p:cNvPr id="10" name="TextBox 9">
-            <a:extLst>
-              <a:ext uri="{FF2B5EF4-FFF2-40B4-BE49-F238E27FC236}">
-                <a16:creationId xmlns:a16="http://schemas.microsoft.com/office/drawing/2014/main" id="{773629AF-B4CC-3758-2F2D-74F80E79F1A9}"/>
-              </a:ext>
-            </a:extLst>
-          </p:cNvPr>
-          <p:cNvSpPr txBox="1"/>
-          <p:nvPr/>
-        </p:nvSpPr>
-        <p:spPr>
-          <a:xfrm>
-            <a:off x="6756640" y="1256446"/>
-            <a:ext cx="4888523" cy="4808752"/>
-          </a:xfrm>
-          <a:prstGeom prst="rect">
-            <a:avLst/>
-          </a:prstGeom>
-          <a:noFill/>
-        </p:spPr>
-        <p:txBody>
-          <a:bodyPr wrap="square" rtlCol="0">
-            <a:spAutoFit/>
-          </a:bodyPr>
-          <a:lstStyle/>
-          <a:p>
-            <a:pPr marL="0" marR="0" lvl="0" indent="0" algn="l" defTabSz="914400" rtl="0" eaLnBrk="1" fontAlgn="auto" latinLnBrk="0" hangingPunct="1">
-              <a:lnSpc>
-                <a:spcPct val="115000"/>
-              </a:lnSpc>
-              <a:spcBef>
-                <a:spcPts val="0"/>
-              </a:spcBef>
-              <a:spcAft>
-                <a:spcPts val="0"/>
-              </a:spcAft>
-              <a:buClrTx/>
-              <a:buSzTx/>
-              <a:buFontTx/>
-              <a:buNone/>
-              <a:tabLst/>
-              <a:defRPr/>
-            </a:pPr>
-            <a:r>
-              <a:rPr kumimoji="0" lang="en-US" sz="1600" b="1" i="0" u="sng" strike="noStrike" kern="1200" cap="none" spc="0" normalizeH="0" baseline="0" noProof="0">
-                <a:ln>
-                  <a:noFill/>
-                </a:ln>
-                <a:solidFill>
-                  <a:srgbClr val="59595B"/>
-                </a:solidFill>
-                <a:effectLst/>
-                <a:uLnTx/>
-                <a:uFillTx/>
-                <a:latin typeface="Arial" panose="020B0604020202020204" pitchFamily="34" charset="0"/>
-                <a:ea typeface="Calibri" panose="020F0502020204030204" pitchFamily="34" charset="0"/>
-                <a:cs typeface="Times New Roman" panose="02020603050405020304" pitchFamily="18" charset="0"/>
-              </a:rPr>
-              <a:t>Evaluation Criteria</a:t>
-            </a:r>
-            <a:r>
-              <a:rPr kumimoji="0" lang="en-US" sz="1200" b="0" i="0" u="none" strike="noStrike" kern="1200" cap="none" spc="0" normalizeH="0" baseline="0" noProof="0">
-                <a:ln>
-                  <a:noFill/>
-                </a:ln>
-                <a:solidFill>
-                  <a:srgbClr val="59595B"/>
-                </a:solidFill>
-                <a:effectLst/>
-                <a:uLnTx/>
-                <a:uFillTx/>
-                <a:latin typeface="Arial" panose="020B0604020202020204" pitchFamily="34" charset="0"/>
-                <a:ea typeface="Calibri" panose="020F0502020204030204" pitchFamily="34" charset="0"/>
-                <a:cs typeface="Times New Roman" panose="02020603050405020304" pitchFamily="18" charset="0"/>
-              </a:rPr>
-              <a:t> (from Course Syllabus)</a:t>
-            </a:r>
-            <a:endParaRPr kumimoji="0" lang="en-US" sz="1600" b="0" i="0" u="none" strike="noStrike" kern="1200" cap="none" spc="0" normalizeH="0" baseline="0" noProof="0">
-              <a:ln>
-                <a:noFill/>
-              </a:ln>
-              <a:solidFill>
-                <a:srgbClr val="59595B"/>
-              </a:solidFill>
-              <a:effectLst/>
-              <a:uLnTx/>
-              <a:uFillTx/>
-              <a:latin typeface="Arial" panose="020B0604020202020204" pitchFamily="34" charset="0"/>
-              <a:ea typeface="Calibri" panose="020F0502020204030204" pitchFamily="34" charset="0"/>
-              <a:cs typeface="Times New Roman" panose="02020603050405020304" pitchFamily="18" charset="0"/>
-            </a:endParaRPr>
-          </a:p>
-          <a:p>
-            <a:pPr marL="0" marR="0" lvl="0" indent="0" algn="l" defTabSz="914400" rtl="0" eaLnBrk="1" fontAlgn="auto" latinLnBrk="0" hangingPunct="1">
-              <a:lnSpc>
-                <a:spcPct val="115000"/>
-              </a:lnSpc>
-              <a:spcBef>
-                <a:spcPts val="0"/>
-              </a:spcBef>
-              <a:spcAft>
-                <a:spcPts val="0"/>
-              </a:spcAft>
-              <a:buClrTx/>
-              <a:buSzTx/>
-              <a:buFontTx/>
-              <a:buNone/>
-              <a:tabLst/>
-              <a:defRPr/>
-            </a:pPr>
-            <a:r>
-              <a:rPr kumimoji="0" lang="en-US" sz="1100" b="1" i="0" u="none" strike="noStrike" kern="1200" cap="none" spc="0" normalizeH="0" baseline="0" noProof="0">
-                <a:ln>
-                  <a:noFill/>
-                </a:ln>
-                <a:solidFill>
-                  <a:srgbClr val="59595B"/>
-                </a:solidFill>
-                <a:effectLst/>
-                <a:uLnTx/>
-                <a:uFillTx/>
-                <a:latin typeface="Arial" panose="020B0604020202020204" pitchFamily="34" charset="0"/>
-                <a:ea typeface="Calibri" panose="020F0502020204030204" pitchFamily="34" charset="0"/>
-                <a:cs typeface="Times New Roman" panose="02020603050405020304" pitchFamily="18" charset="0"/>
-              </a:rPr>
-              <a:t>Support Quality of Work:</a:t>
-            </a:r>
-            <a:endParaRPr kumimoji="0" lang="en-US" sz="1100" b="1" i="0" u="none" strike="noStrike" kern="1200" cap="none" spc="0" normalizeH="0" baseline="0" noProof="0">
-              <a:ln>
-                <a:noFill/>
-              </a:ln>
-              <a:solidFill>
-                <a:srgbClr val="59595B"/>
-              </a:solidFill>
-              <a:effectLst/>
-              <a:uLnTx/>
-              <a:uFillTx/>
-              <a:latin typeface="Calibri" panose="020F0502020204030204" pitchFamily="34" charset="0"/>
-              <a:ea typeface="Calibri" panose="020F0502020204030204" pitchFamily="34" charset="0"/>
-              <a:cs typeface="Times New Roman" panose="02020603050405020304" pitchFamily="18" charset="0"/>
-            </a:endParaRPr>
-          </a:p>
-          <a:p>
-            <a:pPr marL="285750" marR="0" lvl="0" indent="-285750" algn="l" defTabSz="914400" rtl="0" eaLnBrk="1" fontAlgn="auto" latinLnBrk="0" hangingPunct="1">
-              <a:lnSpc>
-                <a:spcPct val="115000"/>
-              </a:lnSpc>
-              <a:spcBef>
-                <a:spcPts val="0"/>
-              </a:spcBef>
-              <a:spcAft>
-                <a:spcPts val="0"/>
-              </a:spcAft>
-              <a:buClrTx/>
-              <a:buSzTx/>
-              <a:buFont typeface="Arial" panose="020B0604020202020204" pitchFamily="34" charset="0"/>
-              <a:buChar char="•"/>
-              <a:tabLst/>
-              <a:defRPr/>
-            </a:pPr>
-            <a:r>
-              <a:rPr kumimoji="0" lang="en-US" sz="1100" b="0" i="0" u="none" strike="noStrike" kern="1200" cap="none" spc="0" normalizeH="0" baseline="0" noProof="0">
-                <a:ln>
-                  <a:noFill/>
-                </a:ln>
-                <a:solidFill>
-                  <a:srgbClr val="59595B"/>
-                </a:solidFill>
-                <a:effectLst/>
-                <a:uLnTx/>
-                <a:uFillTx/>
-                <a:latin typeface="Arial" panose="020B0604020202020204" pitchFamily="34" charset="0"/>
-                <a:ea typeface="Calibri" panose="020F0502020204030204" pitchFamily="34" charset="0"/>
-                <a:cs typeface="Times New Roman" panose="02020603050405020304" pitchFamily="18" charset="0"/>
-              </a:rPr>
-              <a:t>Each statement or explanation is supported by sound facts, logics, or data points.</a:t>
-            </a:r>
-          </a:p>
-          <a:p>
-            <a:pPr marL="285750" marR="0" lvl="0" indent="-285750" algn="l" defTabSz="914400" rtl="0" eaLnBrk="1" fontAlgn="auto" latinLnBrk="0" hangingPunct="1">
-              <a:lnSpc>
-                <a:spcPct val="115000"/>
-              </a:lnSpc>
-              <a:spcBef>
-                <a:spcPts val="0"/>
-              </a:spcBef>
-              <a:spcAft>
-                <a:spcPts val="0"/>
-              </a:spcAft>
-              <a:buClrTx/>
-              <a:buSzTx/>
-              <a:buFont typeface="Arial" panose="020B0604020202020204" pitchFamily="34" charset="0"/>
-              <a:buChar char="•"/>
-              <a:tabLst/>
-              <a:defRPr/>
-            </a:pPr>
-            <a:r>
-              <a:rPr kumimoji="0" lang="en-US" sz="1100" b="0" i="0" u="none" strike="noStrike" kern="1200" cap="none" spc="0" normalizeH="0" baseline="0" noProof="0">
-                <a:ln>
-                  <a:noFill/>
-                </a:ln>
-                <a:solidFill>
-                  <a:srgbClr val="59595B"/>
-                </a:solidFill>
-                <a:effectLst/>
-                <a:uLnTx/>
-                <a:uFillTx/>
-                <a:latin typeface="Arial" panose="020B0604020202020204" pitchFamily="34" charset="0"/>
-                <a:ea typeface="Calibri" panose="020F0502020204030204" pitchFamily="34" charset="0"/>
-                <a:cs typeface="Times New Roman" panose="02020603050405020304" pitchFamily="18" charset="0"/>
-              </a:rPr>
-              <a:t>Analysis yields complex and nuanced syntheses of ideas, demonstrating true understanding.</a:t>
-            </a:r>
-            <a:endParaRPr kumimoji="0" lang="en-US" sz="1100" b="0" i="0" u="none" strike="noStrike" kern="1200" cap="none" spc="0" normalizeH="0" baseline="0" noProof="0">
-              <a:ln>
-                <a:noFill/>
-              </a:ln>
-              <a:solidFill>
-                <a:srgbClr val="59595B"/>
-              </a:solidFill>
-              <a:effectLst/>
-              <a:uLnTx/>
-              <a:uFillTx/>
-              <a:latin typeface="Calibri" panose="020F0502020204030204" pitchFamily="34" charset="0"/>
-              <a:ea typeface="Calibri" panose="020F0502020204030204" pitchFamily="34" charset="0"/>
-              <a:cs typeface="Times New Roman" panose="02020603050405020304" pitchFamily="18" charset="0"/>
-            </a:endParaRPr>
-          </a:p>
-          <a:p>
-            <a:pPr marL="0" marR="0" lvl="0" indent="0" algn="l" defTabSz="914400" rtl="0" eaLnBrk="1" fontAlgn="auto" latinLnBrk="0" hangingPunct="1">
-              <a:lnSpc>
-                <a:spcPct val="115000"/>
-              </a:lnSpc>
-              <a:spcBef>
-                <a:spcPts val="0"/>
-              </a:spcBef>
-              <a:spcAft>
-                <a:spcPts val="0"/>
-              </a:spcAft>
-              <a:buClrTx/>
-              <a:buSzTx/>
-              <a:buFontTx/>
-              <a:buNone/>
-              <a:tabLst/>
-              <a:defRPr/>
-            </a:pPr>
-            <a:r>
-              <a:rPr kumimoji="0" lang="en-US" sz="1100" b="1" i="0" u="none" strike="noStrike" kern="1200" cap="none" spc="0" normalizeH="0" baseline="0" noProof="0">
-                <a:ln>
-                  <a:noFill/>
-                </a:ln>
-                <a:solidFill>
-                  <a:srgbClr val="59595B"/>
-                </a:solidFill>
-                <a:effectLst/>
-                <a:uLnTx/>
-                <a:uFillTx/>
-                <a:latin typeface="Arial" panose="020B0604020202020204" pitchFamily="34" charset="0"/>
-                <a:ea typeface="Calibri" panose="020F0502020204030204" pitchFamily="34" charset="0"/>
-                <a:cs typeface="Times New Roman" panose="02020603050405020304" pitchFamily="18" charset="0"/>
-              </a:rPr>
-              <a:t>Accurate Class Concept Use:</a:t>
-            </a:r>
-            <a:endParaRPr kumimoji="0" lang="en-US" sz="1100" b="1" i="0" u="none" strike="noStrike" kern="1200" cap="none" spc="0" normalizeH="0" baseline="0" noProof="0">
-              <a:ln>
-                <a:noFill/>
-              </a:ln>
-              <a:solidFill>
-                <a:srgbClr val="59595B"/>
-              </a:solidFill>
-              <a:effectLst/>
-              <a:uLnTx/>
-              <a:uFillTx/>
-              <a:latin typeface="Calibri" panose="020F0502020204030204" pitchFamily="34" charset="0"/>
-              <a:ea typeface="Calibri" panose="020F0502020204030204" pitchFamily="34" charset="0"/>
-              <a:cs typeface="Times New Roman" panose="02020603050405020304" pitchFamily="18" charset="0"/>
-            </a:endParaRPr>
-          </a:p>
-          <a:p>
-            <a:pPr marL="285750" marR="0" lvl="0" indent="-285750" algn="l" defTabSz="914400" rtl="0" eaLnBrk="1" fontAlgn="auto" latinLnBrk="0" hangingPunct="1">
-              <a:lnSpc>
-                <a:spcPct val="115000"/>
-              </a:lnSpc>
-              <a:spcBef>
-                <a:spcPts val="0"/>
-              </a:spcBef>
-              <a:spcAft>
-                <a:spcPts val="0"/>
-              </a:spcAft>
-              <a:buClrTx/>
-              <a:buSzTx/>
-              <a:buFont typeface="Arial" panose="020B0604020202020204" pitchFamily="34" charset="0"/>
-              <a:buChar char="•"/>
-              <a:tabLst/>
-              <a:defRPr/>
-            </a:pPr>
-            <a:r>
-              <a:rPr kumimoji="0" lang="en-US" sz="1100" b="0" i="0" u="none" strike="noStrike" kern="1200" cap="none" spc="0" normalizeH="0" baseline="0" noProof="0">
-                <a:ln>
-                  <a:noFill/>
-                </a:ln>
-                <a:solidFill>
-                  <a:srgbClr val="59595B"/>
-                </a:solidFill>
-                <a:effectLst/>
-                <a:uLnTx/>
-                <a:uFillTx/>
-                <a:latin typeface="Arial" panose="020B0604020202020204" pitchFamily="34" charset="0"/>
-                <a:ea typeface="Calibri" panose="020F0502020204030204" pitchFamily="34" charset="0"/>
-                <a:cs typeface="Times New Roman" panose="02020603050405020304" pitchFamily="18" charset="0"/>
-              </a:rPr>
-              <a:t>Class concepts are used throughout the assignment in a manner that demonstrates a full understanding of the concept.</a:t>
-            </a:r>
-            <a:endParaRPr kumimoji="0" lang="en-US" sz="1100" b="0" i="0" u="none" strike="noStrike" kern="1200" cap="none" spc="0" normalizeH="0" baseline="0" noProof="0">
-              <a:ln>
-                <a:noFill/>
-              </a:ln>
-              <a:solidFill>
-                <a:srgbClr val="59595B"/>
-              </a:solidFill>
-              <a:effectLst/>
-              <a:uLnTx/>
-              <a:uFillTx/>
-              <a:latin typeface="Calibri" panose="020F0502020204030204" pitchFamily="34" charset="0"/>
-              <a:ea typeface="Calibri" panose="020F0502020204030204" pitchFamily="34" charset="0"/>
-              <a:cs typeface="Times New Roman" panose="02020603050405020304" pitchFamily="18" charset="0"/>
-            </a:endParaRPr>
-          </a:p>
-          <a:p>
-            <a:pPr marL="0" marR="0" lvl="0" indent="0" algn="l" defTabSz="914400" rtl="0" eaLnBrk="1" fontAlgn="auto" latinLnBrk="0" hangingPunct="1">
-              <a:lnSpc>
-                <a:spcPct val="115000"/>
-              </a:lnSpc>
-              <a:spcBef>
-                <a:spcPts val="0"/>
-              </a:spcBef>
-              <a:spcAft>
-                <a:spcPts val="0"/>
-              </a:spcAft>
-              <a:buClrTx/>
-              <a:buSzTx/>
-              <a:buFontTx/>
-              <a:buNone/>
-              <a:tabLst/>
-              <a:defRPr/>
-            </a:pPr>
-            <a:r>
-              <a:rPr kumimoji="0" lang="en-US" sz="1100" b="1" i="0" u="none" strike="noStrike" kern="1200" cap="none" spc="0" normalizeH="0" baseline="0" noProof="0">
-                <a:ln>
-                  <a:noFill/>
-                </a:ln>
-                <a:solidFill>
-                  <a:srgbClr val="59595B"/>
-                </a:solidFill>
-                <a:effectLst/>
-                <a:uLnTx/>
-                <a:uFillTx/>
-                <a:latin typeface="Arial" panose="020B0604020202020204" pitchFamily="34" charset="0"/>
-                <a:ea typeface="Calibri" panose="020F0502020204030204" pitchFamily="34" charset="0"/>
-                <a:cs typeface="Times New Roman" panose="02020603050405020304" pitchFamily="18" charset="0"/>
-              </a:rPr>
-              <a:t>Critical Thinking:</a:t>
-            </a:r>
-            <a:endParaRPr kumimoji="0" lang="en-US" sz="1100" b="1" i="0" u="none" strike="noStrike" kern="1200" cap="none" spc="0" normalizeH="0" baseline="0" noProof="0">
-              <a:ln>
-                <a:noFill/>
-              </a:ln>
-              <a:solidFill>
-                <a:srgbClr val="59595B"/>
-              </a:solidFill>
-              <a:effectLst/>
-              <a:uLnTx/>
-              <a:uFillTx/>
-              <a:latin typeface="Calibri" panose="020F0502020204030204" pitchFamily="34" charset="0"/>
-              <a:ea typeface="Calibri" panose="020F0502020204030204" pitchFamily="34" charset="0"/>
-              <a:cs typeface="Times New Roman" panose="02020603050405020304" pitchFamily="18" charset="0"/>
-            </a:endParaRPr>
-          </a:p>
-          <a:p>
-            <a:pPr marL="285750" marR="0" lvl="0" indent="-285750" algn="l" defTabSz="914400" rtl="0" eaLnBrk="1" fontAlgn="auto" latinLnBrk="0" hangingPunct="1">
-              <a:lnSpc>
-                <a:spcPct val="115000"/>
-              </a:lnSpc>
-              <a:spcBef>
-                <a:spcPts val="0"/>
-              </a:spcBef>
-              <a:spcAft>
-                <a:spcPts val="0"/>
-              </a:spcAft>
-              <a:buClrTx/>
-              <a:buSzTx/>
-              <a:buFont typeface="Arial" panose="020B0604020202020204" pitchFamily="34" charset="0"/>
-              <a:buChar char="•"/>
-              <a:tabLst/>
-              <a:defRPr/>
-            </a:pPr>
-            <a:r>
-              <a:rPr kumimoji="0" lang="en-US" sz="1100" b="0" i="0" u="none" strike="noStrike" kern="1200" cap="none" spc="0" normalizeH="0" baseline="0" noProof="0">
-                <a:ln>
-                  <a:noFill/>
-                </a:ln>
-                <a:solidFill>
-                  <a:srgbClr val="59595B"/>
-                </a:solidFill>
-                <a:effectLst/>
-                <a:uLnTx/>
-                <a:uFillTx/>
-                <a:latin typeface="Arial" panose="020B0604020202020204" pitchFamily="34" charset="0"/>
-                <a:ea typeface="Calibri" panose="020F0502020204030204" pitchFamily="34" charset="0"/>
-                <a:cs typeface="Times New Roman" panose="02020603050405020304" pitchFamily="18" charset="0"/>
-              </a:rPr>
-              <a:t>Exercises include data and reasoning that confirms or disconfirms the thesis.</a:t>
-            </a:r>
-            <a:endParaRPr kumimoji="0" lang="en-US" sz="1100" b="0" i="0" u="none" strike="noStrike" kern="1200" cap="none" spc="0" normalizeH="0" baseline="0" noProof="0">
-              <a:ln>
-                <a:noFill/>
-              </a:ln>
-              <a:solidFill>
-                <a:srgbClr val="59595B"/>
-              </a:solidFill>
-              <a:effectLst/>
-              <a:uLnTx/>
-              <a:uFillTx/>
-              <a:latin typeface="Calibri" panose="020F0502020204030204" pitchFamily="34" charset="0"/>
-              <a:ea typeface="Calibri" panose="020F0502020204030204" pitchFamily="34" charset="0"/>
-              <a:cs typeface="Times New Roman" panose="02020603050405020304" pitchFamily="18" charset="0"/>
-            </a:endParaRPr>
-          </a:p>
-          <a:p>
-            <a:pPr marL="285750" marR="0" lvl="0" indent="-285750" algn="l" defTabSz="914400" rtl="0" eaLnBrk="1" fontAlgn="auto" latinLnBrk="0" hangingPunct="1">
-              <a:lnSpc>
-                <a:spcPct val="115000"/>
-              </a:lnSpc>
-              <a:spcBef>
-                <a:spcPts val="0"/>
-              </a:spcBef>
-              <a:spcAft>
-                <a:spcPts val="0"/>
-              </a:spcAft>
-              <a:buClrTx/>
-              <a:buSzTx/>
-              <a:buFont typeface="Arial" panose="020B0604020202020204" pitchFamily="34" charset="0"/>
-              <a:buChar char="•"/>
-              <a:tabLst/>
-              <a:defRPr/>
-            </a:pPr>
-            <a:r>
-              <a:rPr kumimoji="0" lang="en-US" sz="1100" b="0" i="0" u="none" strike="noStrike" kern="1200" cap="none" spc="0" normalizeH="0" baseline="0" noProof="0">
-                <a:ln>
-                  <a:noFill/>
-                </a:ln>
-                <a:solidFill>
-                  <a:srgbClr val="59595B"/>
-                </a:solidFill>
-                <a:effectLst/>
-                <a:uLnTx/>
-                <a:uFillTx/>
-                <a:latin typeface="Arial" panose="020B0604020202020204" pitchFamily="34" charset="0"/>
-                <a:ea typeface="Calibri" panose="020F0502020204030204" pitchFamily="34" charset="0"/>
-                <a:cs typeface="Times New Roman" panose="02020603050405020304" pitchFamily="18" charset="0"/>
-              </a:rPr>
-              <a:t>The analysis or explanation demonstrates an understanding of the uncertainty surrounding the facts, logics, and conclusions.</a:t>
-            </a:r>
-            <a:endParaRPr kumimoji="0" lang="en-US" sz="1100" b="0" i="0" u="none" strike="noStrike" kern="1200" cap="none" spc="0" normalizeH="0" baseline="0" noProof="0">
-              <a:ln>
-                <a:noFill/>
-              </a:ln>
-              <a:solidFill>
-                <a:srgbClr val="59595B"/>
-              </a:solidFill>
-              <a:effectLst/>
-              <a:uLnTx/>
-              <a:uFillTx/>
-              <a:latin typeface="Calibri" panose="020F0502020204030204" pitchFamily="34" charset="0"/>
-              <a:ea typeface="Calibri" panose="020F0502020204030204" pitchFamily="34" charset="0"/>
-              <a:cs typeface="Times New Roman" panose="02020603050405020304" pitchFamily="18" charset="0"/>
-            </a:endParaRPr>
-          </a:p>
-          <a:p>
-            <a:pPr marL="0" marR="0" lvl="0" indent="0" algn="l" defTabSz="914400" rtl="0" eaLnBrk="1" fontAlgn="auto" latinLnBrk="0" hangingPunct="1">
-              <a:lnSpc>
-                <a:spcPct val="115000"/>
-              </a:lnSpc>
-              <a:spcBef>
-                <a:spcPts val="0"/>
-              </a:spcBef>
-              <a:spcAft>
-                <a:spcPts val="0"/>
-              </a:spcAft>
-              <a:buClrTx/>
-              <a:buSzTx/>
-              <a:buFontTx/>
-              <a:buNone/>
-              <a:tabLst/>
-              <a:defRPr/>
-            </a:pPr>
-            <a:r>
-              <a:rPr kumimoji="0" lang="en-US" sz="1100" b="1" i="0" u="none" strike="noStrike" kern="1200" cap="none" spc="0" normalizeH="0" baseline="0" noProof="0">
-                <a:ln>
-                  <a:noFill/>
-                </a:ln>
-                <a:solidFill>
-                  <a:srgbClr val="59595B"/>
-                </a:solidFill>
-                <a:effectLst/>
-                <a:uLnTx/>
-                <a:uFillTx/>
-                <a:latin typeface="Arial" panose="020B0604020202020204" pitchFamily="34" charset="0"/>
-                <a:ea typeface="Calibri" panose="020F0502020204030204" pitchFamily="34" charset="0"/>
-                <a:cs typeface="Times New Roman" panose="02020603050405020304" pitchFamily="18" charset="0"/>
-              </a:rPr>
-              <a:t>Mechanics and Professionalism:</a:t>
-            </a:r>
-            <a:endParaRPr kumimoji="0" lang="en-US" sz="1100" b="1" i="0" u="none" strike="noStrike" kern="1200" cap="none" spc="0" normalizeH="0" baseline="0" noProof="0">
-              <a:ln>
-                <a:noFill/>
-              </a:ln>
-              <a:solidFill>
-                <a:srgbClr val="59595B"/>
-              </a:solidFill>
-              <a:effectLst/>
-              <a:uLnTx/>
-              <a:uFillTx/>
-              <a:latin typeface="Calibri" panose="020F0502020204030204" pitchFamily="34" charset="0"/>
-              <a:ea typeface="Calibri" panose="020F0502020204030204" pitchFamily="34" charset="0"/>
-              <a:cs typeface="Times New Roman" panose="02020603050405020304" pitchFamily="18" charset="0"/>
-            </a:endParaRPr>
-          </a:p>
-          <a:p>
-            <a:pPr marL="285750" marR="0" lvl="0" indent="-285750" algn="l" defTabSz="914400" rtl="0" eaLnBrk="1" fontAlgn="auto" latinLnBrk="0" hangingPunct="1">
-              <a:lnSpc>
-                <a:spcPct val="115000"/>
-              </a:lnSpc>
-              <a:spcBef>
-                <a:spcPts val="0"/>
-              </a:spcBef>
-              <a:spcAft>
-                <a:spcPts val="0"/>
-              </a:spcAft>
-              <a:buClrTx/>
-              <a:buSzTx/>
-              <a:buFont typeface="Arial" panose="020B0604020202020204" pitchFamily="34" charset="0"/>
-              <a:buChar char="•"/>
-              <a:tabLst/>
-              <a:defRPr/>
-            </a:pPr>
-            <a:r>
-              <a:rPr kumimoji="0" lang="en-US" sz="1100" b="0" i="0" u="none" strike="noStrike" kern="1200" cap="none" spc="0" normalizeH="0" baseline="0" noProof="0">
-                <a:ln>
-                  <a:noFill/>
-                </a:ln>
-                <a:solidFill>
-                  <a:srgbClr val="59595B"/>
-                </a:solidFill>
-                <a:effectLst/>
-                <a:uLnTx/>
-                <a:uFillTx/>
-                <a:latin typeface="Arial" panose="020B0604020202020204" pitchFamily="34" charset="0"/>
-                <a:ea typeface="Calibri" panose="020F0502020204030204" pitchFamily="34" charset="0"/>
-                <a:cs typeface="Times New Roman" panose="02020603050405020304" pitchFamily="18" charset="0"/>
-              </a:rPr>
-              <a:t>Work is professionally presented and free from grammatical or typographical errors.</a:t>
-            </a:r>
-            <a:endParaRPr kumimoji="0" lang="en-US" sz="1100" b="0" i="0" u="none" strike="noStrike" kern="1200" cap="none" spc="0" normalizeH="0" baseline="0" noProof="0">
-              <a:ln>
-                <a:noFill/>
-              </a:ln>
-              <a:solidFill>
-                <a:srgbClr val="59595B"/>
-              </a:solidFill>
-              <a:effectLst/>
-              <a:uLnTx/>
-              <a:uFillTx/>
-              <a:latin typeface="Calibri" panose="020F0502020204030204" pitchFamily="34" charset="0"/>
-              <a:ea typeface="Calibri" panose="020F0502020204030204" pitchFamily="34" charset="0"/>
-              <a:cs typeface="Times New Roman" panose="02020603050405020304" pitchFamily="18" charset="0"/>
-            </a:endParaRPr>
-          </a:p>
-          <a:p>
-            <a:pPr marL="285750" marR="0" lvl="0" indent="-285750" algn="l" defTabSz="914400" rtl="0" eaLnBrk="1" fontAlgn="auto" latinLnBrk="0" hangingPunct="1">
-              <a:lnSpc>
-                <a:spcPct val="115000"/>
-              </a:lnSpc>
-              <a:spcBef>
-                <a:spcPts val="0"/>
-              </a:spcBef>
-              <a:spcAft>
-                <a:spcPts val="0"/>
-              </a:spcAft>
-              <a:buClrTx/>
-              <a:buSzTx/>
-              <a:buFont typeface="Arial" panose="020B0604020202020204" pitchFamily="34" charset="0"/>
-              <a:buChar char="•"/>
-              <a:tabLst/>
-              <a:defRPr/>
-            </a:pPr>
-            <a:r>
-              <a:rPr kumimoji="0" lang="en-US" sz="1100" b="0" i="0" u="none" strike="noStrike" kern="1200" cap="none" spc="0" normalizeH="0" baseline="0" noProof="0">
-                <a:ln>
-                  <a:noFill/>
-                </a:ln>
-                <a:solidFill>
-                  <a:srgbClr val="59595B"/>
-                </a:solidFill>
-                <a:effectLst/>
-                <a:uLnTx/>
-                <a:uFillTx/>
-                <a:latin typeface="Arial" panose="020B0604020202020204" pitchFamily="34" charset="0"/>
-                <a:ea typeface="Calibri" panose="020F0502020204030204" pitchFamily="34" charset="0"/>
-                <a:cs typeface="Times New Roman" panose="02020603050405020304" pitchFamily="18" charset="0"/>
-              </a:rPr>
-              <a:t>Headings, images, figures, and tables are appropriately and effectively used.</a:t>
-            </a:r>
-            <a:endParaRPr kumimoji="0" lang="en-US" sz="1100" b="0" i="0" u="none" strike="noStrike" kern="1200" cap="none" spc="0" normalizeH="0" baseline="0" noProof="0">
-              <a:ln>
-                <a:noFill/>
-              </a:ln>
-              <a:solidFill>
-                <a:srgbClr val="59595B"/>
-              </a:solidFill>
-              <a:effectLst/>
-              <a:uLnTx/>
-              <a:uFillTx/>
-              <a:latin typeface="Calibri" panose="020F0502020204030204" pitchFamily="34" charset="0"/>
-              <a:ea typeface="Calibri" panose="020F0502020204030204" pitchFamily="34" charset="0"/>
-              <a:cs typeface="Times New Roman" panose="02020603050405020304" pitchFamily="18" charset="0"/>
-            </a:endParaRPr>
-          </a:p>
-          <a:p>
-            <a:pPr marL="0" marR="0" lvl="0" indent="0" algn="l" defTabSz="914400" rtl="0" eaLnBrk="1" fontAlgn="auto" latinLnBrk="0" hangingPunct="1">
-              <a:lnSpc>
-                <a:spcPct val="115000"/>
-              </a:lnSpc>
-              <a:spcBef>
-                <a:spcPts val="0"/>
-              </a:spcBef>
-              <a:spcAft>
-                <a:spcPts val="0"/>
-              </a:spcAft>
-              <a:buClrTx/>
-              <a:buSzTx/>
-              <a:buFontTx/>
-              <a:buNone/>
-              <a:tabLst/>
-              <a:defRPr/>
-            </a:pPr>
-            <a:r>
-              <a:rPr kumimoji="0" lang="en-US" sz="1100" b="1" i="0" u="none" strike="noStrike" kern="1200" cap="none" spc="0" normalizeH="0" baseline="0" noProof="0">
-                <a:ln>
-                  <a:noFill/>
-                </a:ln>
-                <a:solidFill>
-                  <a:srgbClr val="59595B"/>
-                </a:solidFill>
-                <a:effectLst/>
-                <a:uLnTx/>
-                <a:uFillTx/>
-                <a:latin typeface="Arial" panose="020B0604020202020204" pitchFamily="34" charset="0"/>
-                <a:ea typeface="Calibri" panose="020F0502020204030204" pitchFamily="34" charset="0"/>
-                <a:cs typeface="Times New Roman" panose="02020603050405020304" pitchFamily="18" charset="0"/>
-              </a:rPr>
-              <a:t>WOW Factor:</a:t>
-            </a:r>
-            <a:endParaRPr kumimoji="0" lang="en-US" sz="1100" b="1" i="0" u="none" strike="noStrike" kern="1200" cap="none" spc="0" normalizeH="0" baseline="0" noProof="0">
-              <a:ln>
-                <a:noFill/>
-              </a:ln>
-              <a:solidFill>
-                <a:srgbClr val="59595B"/>
-              </a:solidFill>
-              <a:effectLst/>
-              <a:uLnTx/>
-              <a:uFillTx/>
-              <a:latin typeface="Calibri" panose="020F0502020204030204" pitchFamily="34" charset="0"/>
-              <a:ea typeface="Calibri" panose="020F0502020204030204" pitchFamily="34" charset="0"/>
-              <a:cs typeface="Times New Roman" panose="02020603050405020304" pitchFamily="18" charset="0"/>
-            </a:endParaRPr>
-          </a:p>
-          <a:p>
-            <a:pPr marL="171450" marR="0" lvl="0" indent="-171450" algn="l" defTabSz="914400" rtl="0" eaLnBrk="1" fontAlgn="auto" latinLnBrk="0" hangingPunct="1">
-              <a:lnSpc>
-                <a:spcPct val="100000"/>
-              </a:lnSpc>
-              <a:spcBef>
-                <a:spcPts val="0"/>
-              </a:spcBef>
-              <a:spcAft>
-                <a:spcPts val="0"/>
-              </a:spcAft>
-              <a:buClrTx/>
-              <a:buSzTx/>
-              <a:buFont typeface="Arial" panose="020B0604020202020204" pitchFamily="34" charset="0"/>
-              <a:buChar char="•"/>
-              <a:tabLst/>
-              <a:defRPr/>
-            </a:pPr>
-            <a:r>
-              <a:rPr kumimoji="0" lang="en-US" sz="1100" b="0" i="0" u="none" strike="noStrike" kern="1200" cap="none" spc="0" normalizeH="0" baseline="0" noProof="0">
-                <a:ln>
-                  <a:noFill/>
-                </a:ln>
-                <a:solidFill>
-                  <a:srgbClr val="59595B"/>
-                </a:solidFill>
-                <a:effectLst/>
-                <a:uLnTx/>
-                <a:uFillTx/>
-                <a:latin typeface="Arial" panose="020B0604020202020204" pitchFamily="34" charset="0"/>
-                <a:ea typeface="+mn-ea"/>
-                <a:cs typeface="Times New Roman" panose="02020603050405020304" pitchFamily="18" charset="0"/>
-              </a:rPr>
-              <a:t>Approximately 10% of the total grade will be determined by the WOW factor. This is evidence of work that exceeds expectations. These points are reserved for those projects that go beyond assignment requirements and demonstrate creativity, extra effort, and refined professionalism.</a:t>
-            </a:r>
-          </a:p>
-        </p:txBody>
-      </p:sp>
-    </p:spTree>
-    <p:extLst>
-      <p:ext uri="{BB962C8B-B14F-4D97-AF65-F5344CB8AC3E}">
-        <p14:creationId xmlns:p14="http://schemas.microsoft.com/office/powerpoint/2010/main" val="899547087"/>
-      </p:ext>
-    </p:extLst>
-  </p:cSld>
-  <p:clrMapOvr>
-    <a:masterClrMapping/>
-  </p:clrMapOvr>
-</p:sld>
-</file>
-
-<file path=ppt/slides/slide3.xml><?xml version="1.0" encoding="utf-8"?>
-<p:sld xmlns:a="http://schemas.openxmlformats.org/drawingml/2006/main" xmlns:r="http://schemas.openxmlformats.org/officeDocument/2006/relationships" xmlns:p="http://schemas.openxmlformats.org/presentationml/2006/main">
-  <p:cSld>
-    <p:spTree>
-      <p:nvGrpSpPr>
-        <p:cNvPr id="1" name=""/>
-        <p:cNvGrpSpPr/>
-        <p:nvPr/>
-      </p:nvGrpSpPr>
-      <p:grpSpPr>
-        <a:xfrm>
-          <a:off x="0" y="0"/>
-          <a:ext cx="0" cy="0"/>
-          <a:chOff x="0" y="0"/>
-          <a:chExt cx="0" cy="0"/>
-        </a:xfrm>
-      </p:grpSpPr>
-      <p:sp>
-        <p:nvSpPr>
-          <p:cNvPr id="2" name="Title 1">
-            <a:extLst>
-              <a:ext uri="{FF2B5EF4-FFF2-40B4-BE49-F238E27FC236}">
                 <a16:creationId xmlns:a16="http://schemas.microsoft.com/office/drawing/2014/main" id="{807BEDB7-E569-47F3-8EB7-88525EAA092B}"/>
               </a:ext>
             </a:extLst>
@@ -6627,7 +4872,7 @@
 </p:sld>
 </file>
 
-<file path=ppt/slides/slide4.xml><?xml version="1.0" encoding="utf-8"?>
+<file path=ppt/slides/slide2.xml><?xml version="1.0" encoding="utf-8"?>
 <p:sld xmlns:a="http://schemas.openxmlformats.org/drawingml/2006/main" xmlns:r="http://schemas.openxmlformats.org/officeDocument/2006/relationships" xmlns:p="http://schemas.openxmlformats.org/presentationml/2006/main">
   <p:cSld>
     <p:spTree>
@@ -6751,7 +4996,7 @@
 </p:sld>
 </file>
 
-<file path=ppt/slides/slide5.xml><?xml version="1.0" encoding="utf-8"?>
+<file path=ppt/slides/slide3.xml><?xml version="1.0" encoding="utf-8"?>
 <p:sld xmlns:a="http://schemas.openxmlformats.org/drawingml/2006/main" xmlns:r="http://schemas.openxmlformats.org/officeDocument/2006/relationships" xmlns:p="http://schemas.openxmlformats.org/presentationml/2006/main">
   <p:cSld>
     <p:spTree>
@@ -6888,7 +5133,7 @@
         </p:nvSpPr>
         <p:spPr>
           <a:xfrm>
-            <a:off x="744278" y="1297172"/>
+            <a:off x="608076" y="1600204"/>
             <a:ext cx="10972799" cy="584791"/>
           </a:xfrm>
           <a:prstGeom prst="roundRect">
@@ -6916,6 +5161,10 @@
           <a:lstStyle/>
           <a:p>
             <a:pPr algn="ctr"/>
+            <a:r>
+              <a:rPr lang="en-US"/>
+              <a:t>Note to IC: </a:t>
+            </a:r>
             <a:r>
               <a:rPr lang="en-US" dirty="0"/>
               <a:t>In this assignment I will focus on the Wireless Semiconductor Division of Broadcom </a:t>
@@ -6943,7 +5192,7 @@
 </p:sld>
 </file>
 
-<file path=ppt/slides/slide6.xml><?xml version="1.0" encoding="utf-8"?>
+<file path=ppt/slides/slide4.xml><?xml version="1.0" encoding="utf-8"?>
 <p:sld xmlns:a="http://schemas.openxmlformats.org/drawingml/2006/main" xmlns:r="http://schemas.openxmlformats.org/officeDocument/2006/relationships" xmlns:p="http://schemas.openxmlformats.org/presentationml/2006/main">
   <p:cSld>
     <p:spTree>
@@ -7034,7 +5283,7 @@
 </p:sld>
 </file>
 
-<file path=ppt/slides/slide7.xml><?xml version="1.0" encoding="utf-8"?>
+<file path=ppt/slides/slide5.xml><?xml version="1.0" encoding="utf-8"?>
 <p:sld xmlns:a="http://schemas.openxmlformats.org/drawingml/2006/main" xmlns:r="http://schemas.openxmlformats.org/officeDocument/2006/relationships" xmlns:p="http://schemas.openxmlformats.org/presentationml/2006/main">
   <p:cSld>
     <p:spTree>
@@ -10023,7 +8272,7 @@
 </p:sld>
 </file>
 
-<file path=ppt/slides/slide8.xml><?xml version="1.0" encoding="utf-8"?>
+<file path=ppt/slides/slide6.xml><?xml version="1.0" encoding="utf-8"?>
 <p:sld xmlns:a="http://schemas.openxmlformats.org/drawingml/2006/main" xmlns:r="http://schemas.openxmlformats.org/officeDocument/2006/relationships" xmlns:p="http://schemas.openxmlformats.org/presentationml/2006/main">
   <p:cSld>
     <p:spTree>

</xml_diff>